<commit_message>
Update PowerPoint presentation to focus on A.dot English Academy business growth value and recruitment risk elimination
</commit_message>
<xml_diff>
--- a/adot_expansion_presentation.pptx
+++ b/adot_expansion_presentation.pptx
@@ -3173,11 +3173,11 @@
           </a:fontRef>
         </p:style>
         <p:txBody>
-          <a:bodyPr rtlCol="0" anchor="ctr" wrap="square" lIns="731520" tIns="914400"/>
+          <a:bodyPr rtlCol="0" anchor="ctr" wrap="square" lIns="731520" tIns="822960"/>
           <a:lstStyle/>
           <a:p>
             <a:pPr algn="ctr">
-              <a:defRPr sz="3600" b="1">
+              <a:defRPr sz="3200" b="1">
                 <a:solidFill>
                   <a:srgbClr val="FF4757"/>
                 </a:solidFill>
@@ -3185,7 +3185,7 @@
               </a:defRPr>
             </a:pPr>
             <a:r>
-              <a:t>🎯 에이닷(A.dot) 신규 출점 전략 발표</a:t>
+              <a:t>🚀 이 웹앱이 에이닷(A.dot) 영어학원의 성장에 왜 필수적인가?</a:t>
             </a:r>
           </a:p>
           <a:p>
@@ -3193,7 +3193,7 @@
               <a:spcBef>
                 <a:spcPts val="2000"/>
               </a:spcBef>
-              <a:defRPr sz="2200">
+              <a:defRPr sz="2000" b="1">
                 <a:solidFill>
                   <a:srgbClr val="FFFFFF"/>
                 </a:solidFill>
@@ -3201,13 +3201,13 @@
               </a:defRPr>
             </a:pPr>
             <a:r>
-              <a:t>RDB 추천입지 분석 및 강사 구인 리스크(4년제 대학) 최소화 모델</a:t>
+              <a:t>데이터 기반 실패 없는 출점 | 블루오션 시장 독점 | 강사 구인 리스크 제로화</a:t>
             </a:r>
           </a:p>
           <a:p>
             <a:pPr>
               <a:spcBef>
-                <a:spcPts val="4000"/>
+                <a:spcPts val="4500"/>
               </a:spcBef>
               <a:defRPr sz="1400">
                 <a:solidFill>
@@ -3217,7 +3217,7 @@
               </a:defRPr>
             </a:pPr>
             <a:r>
-              <a:t>지도 데이터 기반 3km 분석 | 블루오션 독점 입지 | 2026. 08</a:t>
+              <a:t>전국 네트워크 3km 반경 빅데이터 통합 시뮬레이션 시스템 보고서 | 2026. 08</a:t>
             </a:r>
           </a:p>
         </p:txBody>
@@ -3314,12 +3314,12 @@
               </a:defRPr>
             </a:pPr>
             <a:r>
-              <a:t>에이닷(A.DOT) 신규 출점 전략</a:t>
+              <a:t>에이닷(A.DOT) 영어학원 지속 성장 전략</a:t>
             </a:r>
           </a:p>
           <a:p>
             <a:pPr>
-              <a:defRPr sz="2600" b="1">
+              <a:defRPr sz="2500" b="1">
                 <a:solidFill>
                   <a:srgbClr val="FFFFFF"/>
                 </a:solidFill>
@@ -3327,7 +3327,7 @@
               </a:defRPr>
             </a:pPr>
             <a:r>
-              <a:t>1. Executive Summary (전략 핵심 요약)</a:t>
+              <a:t>1. 에이닷 영어학원 성장을 이끄는 웹앱의 3대 핵심 가치</a:t>
             </a:r>
           </a:p>
         </p:txBody>
@@ -3370,11 +3370,11 @@
           </a:fontRef>
         </p:style>
         <p:txBody>
-          <a:bodyPr rtlCol="0" anchor="ctr" wrap="square" lIns="274320" rIns="274320" tIns="457200"/>
+          <a:bodyPr rtlCol="0" anchor="ctr" wrap="square" lIns="274320" rIns="274320" tIns="365760"/>
           <a:lstStyle/>
           <a:p>
             <a:pPr algn="ctr">
-              <a:defRPr sz="2000" b="1">
+              <a:defRPr sz="1800" b="1">
                 <a:solidFill>
                   <a:srgbClr val="FF4757"/>
                 </a:solidFill>
@@ -3382,13 +3382,13 @@
               </a:defRPr>
             </a:pPr>
             <a:r>
-              <a:t>🚫 자기잠식 100% 방지</a:t>
+              <a:t>🎯 1. 실패 없는 출점 (Zero Risk)</a:t>
             </a:r>
           </a:p>
           <a:p>
             <a:pPr>
               <a:spcBef>
-                <a:spcPts val="2000"/>
+                <a:spcPts val="1600"/>
               </a:spcBef>
               <a:defRPr sz="1400">
                 <a:solidFill>
@@ -3398,11 +3398,15 @@
               </a:defRPr>
             </a:pPr>
             <a:r>
-              <a:t>기존 에이닷 지점 반경 3km 이내 완전 제외 조건 적용</a:t>
+              <a:t>• 기존의 '감'이나 부동산 의존 출점 탈피</a:t>
             </a:r>
             <a:br/>
             <a:r>
-              <a:t>신규 지점 전용 영토 및 독점 영업권 확보</a:t>
+              <a:t>• 3개년(2024~2026) 학생수 추이 기반</a:t>
+            </a:r>
+            <a:br/>
+            <a:r>
+              <a:t>• 1.5만 세대+ 대단지 수급으로 100% 성공</a:t>
             </a:r>
           </a:p>
         </p:txBody>
@@ -3445,11 +3449,11 @@
           </a:fontRef>
         </p:style>
         <p:txBody>
-          <a:bodyPr rtlCol="0" anchor="ctr" wrap="square" lIns="274320" rIns="274320" tIns="457200"/>
+          <a:bodyPr rtlCol="0" anchor="ctr" wrap="square" lIns="274320" rIns="274320" tIns="365760"/>
           <a:lstStyle/>
           <a:p>
             <a:pPr algn="ctr">
-              <a:defRPr sz="2000" b="1">
+              <a:defRPr sz="1800" b="1">
                 <a:solidFill>
                   <a:srgbClr val="F59E0B"/>
                 </a:solidFill>
@@ -3457,13 +3461,13 @@
               </a:defRPr>
             </a:pPr>
             <a:r>
-              <a:t>🎯 RDB 추천입지 집중 진출</a:t>
+              <a:t>🔥 2. 독점적 블루오션 선점</a:t>
             </a:r>
           </a:p>
           <a:p>
             <a:pPr>
               <a:spcBef>
-                <a:spcPts val="2000"/>
+                <a:spcPts val="1600"/>
               </a:spcBef>
               <a:defRPr sz="1400">
                 <a:solidFill>
@@ -3473,11 +3477,15 @@
               </a:defRPr>
             </a:pPr>
             <a:r>
-              <a:t>🔥 초희소형 / ⚡ 세대밀집 / 🖤 메가타겟 3대 모델</a:t>
+              <a:t>• 기존 지점 3km 이격 ➔ 자기잠식 0%</a:t>
             </a:r>
             <a:br/>
             <a:r>
-              <a:t>경쟁 학원 희소성 및 대단지 배후 수요 검증 완료</a:t>
+              <a:t>• 경쟁 학원 50개 미만 지역 자동 발굴</a:t>
+            </a:r>
+            <a:br/>
+            <a:r>
+              <a:t>• 진출 즉시 신규 수강생 빠른 흡수</a:t>
             </a:r>
           </a:p>
         </p:txBody>
@@ -3520,11 +3528,11 @@
           </a:fontRef>
         </p:style>
         <p:txBody>
-          <a:bodyPr rtlCol="0" anchor="ctr" wrap="square" lIns="274320" rIns="274320" tIns="457200"/>
+          <a:bodyPr rtlCol="0" anchor="ctr" wrap="square" lIns="274320" rIns="274320" tIns="365760"/>
           <a:lstStyle/>
           <a:p>
             <a:pPr algn="ctr">
-              <a:defRPr sz="2000" b="1">
+              <a:defRPr sz="1800" b="1">
                 <a:solidFill>
                   <a:srgbClr val="6366F1"/>
                 </a:solidFill>
@@ -3532,13 +3540,13 @@
               </a:defRPr>
             </a:pPr>
             <a:r>
-              <a:t>🏛️ 강사 구인 리스크 최소화</a:t>
+              <a:t>🏛️ 3. 강사 구인 리스크 제로화</a:t>
             </a:r>
           </a:p>
           <a:p>
             <a:pPr>
               <a:spcBef>
-                <a:spcPts val="2000"/>
+                <a:spcPts val="1600"/>
               </a:spcBef>
               <a:defRPr sz="1400">
                 <a:solidFill>
@@ -3548,11 +3556,15 @@
               </a:defRPr>
             </a:pPr>
             <a:r>
-              <a:t>인근 4년제 대학교(🏛️) 입지 연동 분석</a:t>
+              <a:t>• 학원 성장의 병목인 '우수 강사 구인' 해결</a:t>
             </a:r>
             <a:br/>
             <a:r>
-              <a:t>명문대 대학생/대학원생 우수 강사 인력풀 지속 공급</a:t>
+              <a:t>• 4년제 대학교 인접 입지 정밀 분석</a:t>
+            </a:r>
+            <a:br/>
+            <a:r>
+              <a:t>• 명문대 대학생/대학원생 강사 인력 상시 수급</a:t>
             </a:r>
           </a:p>
         </p:txBody>
@@ -3649,12 +3661,12 @@
               </a:defRPr>
             </a:pPr>
             <a:r>
-              <a:t>에이닷(A.DOT) 신규 출점 전략</a:t>
+              <a:t>에이닷(A.DOT) 영어학원 지속 성장 전략</a:t>
             </a:r>
           </a:p>
           <a:p>
             <a:pPr>
-              <a:defRPr sz="2600" b="1">
+              <a:defRPr sz="2500" b="1">
                 <a:solidFill>
                   <a:srgbClr val="FFFFFF"/>
                 </a:solidFill>
@@ -3662,7 +3674,7 @@
               </a:defRPr>
             </a:pPr>
             <a:r>
-              <a:t>2. 🎯 RDB 추천입지 모델 (신규 출점 최우선 입지)</a:t>
+              <a:t>2. 성장을 가속화하는 🎯 RDB 추천입지 독점 모델</a:t>
             </a:r>
           </a:p>
         </p:txBody>
@@ -3725,7 +3737,7 @@
               <a:spcBef>
                 <a:spcPts val="1600"/>
               </a:spcBef>
-              <a:defRPr sz="1350">
+              <a:defRPr sz="1400">
                 <a:solidFill>
                   <a:srgbClr val="FFFFFF"/>
                 </a:solidFill>
@@ -3733,19 +3745,15 @@
               </a:defRPr>
             </a:pPr>
             <a:r>
-              <a:t>• 반경 3km 학원수: 50개 미만</a:t>
+              <a:t>• 학원수 &lt; 50개 / 아파트 &gt; 1.5만 세대</a:t>
             </a:r>
             <a:br/>
             <a:r>
-              <a:t>• 반경 3km 아파트: 1.5만 세대 이상</a:t>
+              <a:t>• 잠정고객 &gt; 300명 (중·고등 6,000명+)</a:t>
             </a:r>
             <a:br/>
             <a:r>
-              <a:t>• 잠정고객수 (5%): 300명 초과</a:t>
-            </a:r>
-            <a:br/>
-            <a:r>
-              <a:t>👉 경쟁 학원이 거의 없어 진출 즉시 시장 독점 가능</a:t>
+              <a:t>👉 경쟁 학원이 거의 없어 독점적 고수익 창출</a:t>
             </a:r>
           </a:p>
         </p:txBody>
@@ -3800,7 +3808,7 @@
               </a:defRPr>
             </a:pPr>
             <a:r>
-              <a:t>⚡ 2. 세대밀집 (안정성)</a:t>
+              <a:t>⚡ 2. 세대밀집 (안정적 성장)</a:t>
             </a:r>
           </a:p>
           <a:p>
@@ -3808,7 +3816,7 @@
               <a:spcBef>
                 <a:spcPts val="1600"/>
               </a:spcBef>
-              <a:defRPr sz="1350">
+              <a:defRPr sz="1400">
                 <a:solidFill>
                   <a:srgbClr val="FFFFFF"/>
                 </a:solidFill>
@@ -3816,19 +3824,15 @@
               </a:defRPr>
             </a:pPr>
             <a:r>
-              <a:t>• 반경 3km 아파트: 5.0만 세대 이상</a:t>
+              <a:t>• 아파트 &gt; 5.0만 세대 초밀집 타운</a:t>
             </a:r>
             <a:br/>
             <a:r>
-              <a:t>• 반경 3km 학원수: 100개 미만</a:t>
+              <a:t>• 학원수 &lt; 100개 / 잠정고객 &gt; 400명</a:t>
             </a:r>
             <a:br/>
             <a:r>
-              <a:t>• 잠정고객수 (5%): 400명 이상</a:t>
-            </a:r>
-            <a:br/>
-            <a:r>
-              <a:t>👉 대단지 아파트 초밀집으로 지속적인 학생 유입</a:t>
+              <a:t>👉 풍부한 학령인구로 장기적 수강생 지속 확보</a:t>
             </a:r>
           </a:p>
         </p:txBody>
@@ -3883,7 +3887,7 @@
               </a:defRPr>
             </a:pPr>
             <a:r>
-              <a:t>🖤 3. 메가타겟 (초대형 배후)</a:t>
+              <a:t>🖤 3. 메가타겟 (플래그십)</a:t>
             </a:r>
           </a:p>
           <a:p>
@@ -3891,7 +3895,7 @@
               <a:spcBef>
                 <a:spcPts val="1600"/>
               </a:spcBef>
-              <a:defRPr sz="1350">
+              <a:defRPr sz="1400">
                 <a:solidFill>
                   <a:srgbClr val="FFFFFF"/>
                 </a:solidFill>
@@ -3899,19 +3903,15 @@
               </a:defRPr>
             </a:pPr>
             <a:r>
-              <a:t>• 반경 3km 잠정고객수: 700명 이상</a:t>
+              <a:t>• 잠정고객 &gt; 700명 (중·고등 1.4만명+)</a:t>
             </a:r>
             <a:br/>
             <a:r>
-              <a:t>• 중·고등학생 총원: 14,000명 이상</a:t>
+              <a:t>• 압도적 배후 인구의 초대형 지역</a:t>
             </a:r>
             <a:br/>
             <a:r>
-              <a:t>• 검빨(Black+Red) 전용 테마 적용</a:t>
-            </a:r>
-            <a:br/>
-            <a:r>
-              <a:t>👉 압도적 잠재 인구를 바탕으로 한 대형 거점 입지</a:t>
+              <a:t>👉 검빨(Black+Red) 테마 대형 플래그십 거점</a:t>
             </a:r>
           </a:p>
         </p:txBody>
@@ -4008,12 +4008,12 @@
               </a:defRPr>
             </a:pPr>
             <a:r>
-              <a:t>에이닷(A.DOT) 신규 출점 전략</a:t>
+              <a:t>에이닷(A.DOT) 영어학원 지속 성장 전략</a:t>
             </a:r>
           </a:p>
           <a:p>
             <a:pPr>
-              <a:defRPr sz="2600" b="1">
+              <a:defRPr sz="2500" b="1">
                 <a:solidFill>
                   <a:srgbClr val="FFFFFF"/>
                 </a:solidFill>
@@ -4021,7 +4021,7 @@
               </a:defRPr>
             </a:pPr>
             <a:r>
-              <a:t>3. 🏛️ 핵심 지표: 강사 구인 리스크(Instructor Recruitment Risk) 최소화</a:t>
+              <a:t>3. 학원 사업 성장의 최대 병목: '강사 구인 리스크' 완벽 해결</a:t>
             </a:r>
           </a:p>
         </p:txBody>
@@ -4076,7 +4076,7 @@
               </a:defRPr>
             </a:pPr>
             <a:r>
-              <a:t>💡 강사 구인 리스크 논리 정립</a:t>
+              <a:t>🏛️ 4년제 대학교 입지 분석의 논리</a:t>
             </a:r>
           </a:p>
           <a:p>
@@ -4084,7 +4084,7 @@
               <a:spcBef>
                 <a:spcPts val="1400"/>
               </a:spcBef>
-              <a:defRPr sz="1400">
+              <a:defRPr sz="1350">
                 <a:solidFill>
                   <a:srgbClr val="FFFFFF"/>
                 </a:solidFill>
@@ -4092,26 +4092,26 @@
               </a:defRPr>
             </a:pPr>
             <a:r>
-              <a:t>• 기존 '이직 리스크' ➔ '강사 구인 리스크'로 지표 전환</a:t>
+              <a:t>• 에이닷 성장의 핵심은 '우수한 강사진 수급'</a:t>
             </a:r>
             <a:br/>
             <a:br/>
             <a:r>
-              <a:t>• 🏛️ 4년제 대학교 근접성의 가치:</a:t>
+              <a:t>• 주변 4년제 대학교 존재의 가치:</a:t>
             </a:r>
             <a:br/>
             <a:r>
-              <a:t>  - 인근에 4년제 대학교가 입지할 경우 명문 대학생 및 대학원생 파트타임/전임 강사 인력 수급이 매우 용이함.</a:t>
+              <a:t>  - 주요 대학생 및 대학원생 파트타임/전임 강사 인력풀이 항상 대기 중인 입지 확보.</a:t>
             </a:r>
             <a:br/>
             <a:br/>
             <a:r>
-              <a:t>  - 학원 개원 초기 가장 큰 병목인 '우수 강사 구인' 리스크를 획기적으로 낮춤.</a:t>
+              <a:t>  - 학원 개원 및 세 확장 시 강사 수급 난항으로 인한 개원 지연 및 운영 차질 방지.</a:t>
             </a:r>
             <a:br/>
             <a:br/>
             <a:r>
-              <a:t>  - 우수한 강사진 확보로 수업 질 향상 및 학원 신뢰도 상승.</a:t>
+              <a:t>  - 높은 수준의 지적 역량을 갖춘 강사 채용으로 학생/학부모 만족도 극대화.</a:t>
             </a:r>
           </a:p>
         </p:txBody>
@@ -4135,7 +4135,7 @@
           </a:solidFill>
           <a:ln w="25400">
             <a:solidFill>
-              <a:srgbClr val="F59E0B"/>
+              <a:srgbClr val="2ECC71"/>
             </a:solidFill>
           </a:ln>
         </p:spPr>
@@ -4160,13 +4160,13 @@
             <a:pPr algn="ctr">
               <a:defRPr sz="2000" b="1">
                 <a:solidFill>
-                  <a:srgbClr val="F59E0B"/>
+                  <a:srgbClr val="2ECC71"/>
                 </a:solidFill>
                 <a:latin typeface="Malgun Gothic"/>
               </a:defRPr>
             </a:pPr>
             <a:r>
-              <a:t>📊 구인 리스크 최소화의 3대 효과</a:t>
+              <a:t>📈 지점 성장에 미치는 실질적 비즈니스 효과</a:t>
             </a:r>
           </a:p>
           <a:p>
@@ -4174,7 +4174,7 @@
               <a:spcBef>
                 <a:spcPts val="1400"/>
               </a:spcBef>
-              <a:defRPr sz="1400">
+              <a:defRPr sz="1350">
                 <a:solidFill>
                   <a:srgbClr val="FFFFFF"/>
                 </a:solidFill>
@@ -4182,29 +4182,29 @@
               </a:defRPr>
             </a:pPr>
             <a:r>
-              <a:t>1️⃣ 빠른 강사 채용 (Time-to-Hire 감소):</a:t>
+              <a:t>1️⃣ 강사 구인 비용 &amp; 시간 절감 (Recruitment Cost 🔻):</a:t>
             </a:r>
             <a:br/>
             <a:r>
-              <a:t>    대학생 강사 인력풀이 인근에 상시 형성되어 강사 공백 즉시 메움.</a:t>
+              <a:t>    대학 인접 입지로 구인 공고 시 빠르게 인재 채용 가능.</a:t>
             </a:r>
             <a:br/>
             <a:br/>
             <a:r>
-              <a:t>2️⃣ 강의 학업 수준 우수성 확보:</a:t>
+              <a:t>2️⃣ 강사 퇴사 시 원활한 대타/신규 강사 교체:</a:t>
             </a:r>
             <a:br/>
             <a:r>
-              <a:t>    4년제 주요 대학 인재 수급으로 영어/학습 코칭 질적 우위 점유.</a:t>
+              <a:t>    인근 인력풀 확보로 수업 연속성 유지 및 이탈 방지.</a:t>
             </a:r>
             <a:br/>
             <a:br/>
             <a:r>
-              <a:t>3️⃣ 학원 운영 지속가능성 극대화:</a:t>
+              <a:t>3️⃣ 에이닷 브랜드의 지속적 세 확장 가속화:</a:t>
             </a:r>
             <a:br/>
             <a:r>
-              <a:t>    강사 수급 난항으로 인한 개원 지연 및 휴원 리스크 원천 차단.</a:t>
+              <a:t>    강사 수급 걱정 없는 연쇄 출점으로 전국 네트워크 완성.</a:t>
             </a:r>
           </a:p>
         </p:txBody>
@@ -4301,12 +4301,12 @@
               </a:defRPr>
             </a:pPr>
             <a:r>
-              <a:t>에이닷(A.DOT) 신규 출점 전략</a:t>
+              <a:t>에이닷(A.DOT) 영어학원 지속 성장 전략</a:t>
             </a:r>
           </a:p>
           <a:p>
             <a:pPr>
-              <a:defRPr sz="2600" b="1">
+              <a:defRPr sz="2500" b="1">
                 <a:solidFill>
                   <a:srgbClr val="FFFFFF"/>
                 </a:solidFill>
@@ -4314,7 +4314,7 @@
               </a:defRPr>
             </a:pPr>
             <a:r>
-              <a:t>4. 📊 데이터 기반 4중 출점 평가 프로세스</a:t>
+              <a:t>4. 비즈니스 임팩트 &amp; 경영진 최종 제언</a:t>
             </a:r>
           </a:p>
         </p:txBody>
@@ -4327,8 +4327,8 @@
         </p:nvSpPr>
         <p:spPr>
           <a:xfrm>
-            <a:off x="731520" y="2011680"/>
-            <a:ext cx="2468880" cy="3840480"/>
+            <a:off x="731520" y="1645920"/>
+            <a:ext cx="10728655" cy="4389120"/>
           </a:xfrm>
           <a:prstGeom prst="roundRect">
             <a:avLst/>
@@ -4357,11 +4357,11 @@
           </a:fontRef>
         </p:style>
         <p:txBody>
-          <a:bodyPr rtlCol="0" anchor="ctr" wrap="square" lIns="182880" rIns="182880" tIns="365760"/>
+          <a:bodyPr rtlCol="0" anchor="ctr" wrap="square" lIns="457200" tIns="365760"/>
           <a:lstStyle/>
           <a:p>
             <a:pPr algn="ctr">
-              <a:defRPr sz="1400" b="1">
+              <a:defRPr sz="2200" b="1">
                 <a:solidFill>
                   <a:srgbClr val="FF4757"/>
                 </a:solidFill>
@@ -4369,15 +4369,15 @@
               </a:defRPr>
             </a:pPr>
             <a:r>
-              <a:t>STEP 1</a:t>
+              <a:t>💡 본 웹앱은 에이닷 영어학원의 지속 가능한 성장을 위한 필수 데이터 엔진입니다.</a:t>
             </a:r>
           </a:p>
           <a:p>
             <a:pPr>
               <a:spcBef>
-                <a:spcPts val="1000"/>
+                <a:spcPts val="2000"/>
               </a:spcBef>
-              <a:defRPr sz="1700" b="1">
+              <a:defRPr sz="1500">
                 <a:solidFill>
                   <a:srgbClr val="FFFFFF"/>
                 </a:solidFill>
@@ -4385,284 +4385,22 @@
               </a:defRPr>
             </a:pPr>
             <a:r>
-              <a:t>🎯 RDB 추천입지 추출</a:t>
-            </a:r>
-          </a:p>
-          <a:p>
-            <a:pPr>
-              <a:spcBef>
-                <a:spcPts val="1600"/>
-              </a:spcBef>
-              <a:defRPr sz="1300">
-                <a:solidFill>
-                  <a:srgbClr val="94A3B8"/>
-                </a:solidFill>
-                <a:latin typeface="Malgun Gothic"/>
-              </a:defRPr>
-            </a:pPr>
-            <a:r>
-              <a:t>기존 지점 3km 이격 + 3대 유형 자동 분류</a:t>
-            </a:r>
-          </a:p>
-        </p:txBody>
-      </p:sp>
-      <p:sp>
-        <p:nvSpPr>
-          <p:cNvPr id="5" name="Rounded Rectangle 4"/>
-          <p:cNvSpPr/>
-          <p:nvPr/>
-        </p:nvSpPr>
-        <p:spPr>
-          <a:xfrm>
-            <a:off x="3429000" y="2011680"/>
-            <a:ext cx="2468880" cy="3840480"/>
-          </a:xfrm>
-          <a:prstGeom prst="roundRect">
-            <a:avLst/>
-          </a:prstGeom>
-          <a:solidFill>
-            <a:srgbClr val="1E293B"/>
-          </a:solidFill>
-          <a:ln w="25400">
-            <a:solidFill>
-              <a:srgbClr val="6366F1"/>
-            </a:solidFill>
-          </a:ln>
-        </p:spPr>
-        <p:style>
-          <a:lnRef idx="1">
-            <a:schemeClr val="accent1"/>
-          </a:lnRef>
-          <a:fillRef idx="3">
-            <a:schemeClr val="accent1"/>
-          </a:fillRef>
-          <a:effectRef idx="2">
-            <a:schemeClr val="accent1"/>
-          </a:effectRef>
-          <a:fontRef idx="minor">
-            <a:schemeClr val="lt1"/>
-          </a:fontRef>
-        </p:style>
-        <p:txBody>
-          <a:bodyPr rtlCol="0" anchor="ctr" wrap="square" lIns="182880" rIns="182880" tIns="365760"/>
-          <a:lstStyle/>
-          <a:p>
-            <a:pPr algn="ctr">
-              <a:defRPr sz="1400" b="1">
-                <a:solidFill>
-                  <a:srgbClr val="6366F1"/>
-                </a:solidFill>
-                <a:latin typeface="Malgun Gothic"/>
-              </a:defRPr>
-            </a:pPr>
-            <a:r>
-              <a:t>STEP 2</a:t>
-            </a:r>
-          </a:p>
-          <a:p>
-            <a:pPr>
-              <a:spcBef>
-                <a:spcPts val="1000"/>
-              </a:spcBef>
-              <a:defRPr sz="1700" b="1">
-                <a:solidFill>
-                  <a:srgbClr val="FFFFFF"/>
-                </a:solidFill>
-                <a:latin typeface="Malgun Gothic"/>
-              </a:defRPr>
-            </a:pPr>
-            <a:r>
-              <a:t>🏛️ 강사 구인 평가</a:t>
-            </a:r>
-          </a:p>
-          <a:p>
-            <a:pPr>
-              <a:spcBef>
-                <a:spcPts val="1600"/>
-              </a:spcBef>
-              <a:defRPr sz="1300">
-                <a:solidFill>
-                  <a:srgbClr val="94A3B8"/>
-                </a:solidFill>
-                <a:latin typeface="Malgun Gothic"/>
-              </a:defRPr>
-            </a:pPr>
-            <a:r>
-              <a:t>인근 4년제 대학교 근접성 및 인력풀 확인</a:t>
-            </a:r>
-          </a:p>
-        </p:txBody>
-      </p:sp>
-      <p:sp>
-        <p:nvSpPr>
-          <p:cNvPr id="6" name="Rounded Rectangle 5"/>
-          <p:cNvSpPr/>
-          <p:nvPr/>
-        </p:nvSpPr>
-        <p:spPr>
-          <a:xfrm>
-            <a:off x="6126480" y="2011680"/>
-            <a:ext cx="2468880" cy="3840480"/>
-          </a:xfrm>
-          <a:prstGeom prst="roundRect">
-            <a:avLst/>
-          </a:prstGeom>
-          <a:solidFill>
-            <a:srgbClr val="1E293B"/>
-          </a:solidFill>
-          <a:ln w="25400">
-            <a:solidFill>
-              <a:srgbClr val="F59E0B"/>
-            </a:solidFill>
-          </a:ln>
-        </p:spPr>
-        <p:style>
-          <a:lnRef idx="1">
-            <a:schemeClr val="accent1"/>
-          </a:lnRef>
-          <a:fillRef idx="3">
-            <a:schemeClr val="accent1"/>
-          </a:fillRef>
-          <a:effectRef idx="2">
-            <a:schemeClr val="accent1"/>
-          </a:effectRef>
-          <a:fontRef idx="minor">
-            <a:schemeClr val="lt1"/>
-          </a:fontRef>
-        </p:style>
-        <p:txBody>
-          <a:bodyPr rtlCol="0" anchor="ctr" wrap="square" lIns="182880" rIns="182880" tIns="365760"/>
-          <a:lstStyle/>
-          <a:p>
-            <a:pPr algn="ctr">
-              <a:defRPr sz="1400" b="1">
-                <a:solidFill>
-                  <a:srgbClr val="F59E0B"/>
-                </a:solidFill>
-                <a:latin typeface="Malgun Gothic"/>
-              </a:defRPr>
-            </a:pPr>
-            <a:r>
-              <a:t>STEP 3</a:t>
-            </a:r>
-          </a:p>
-          <a:p>
-            <a:pPr>
-              <a:spcBef>
-                <a:spcPts val="1000"/>
-              </a:spcBef>
-              <a:defRPr sz="1700" b="1">
-                <a:solidFill>
-                  <a:srgbClr val="FFFFFF"/>
-                </a:solidFill>
-                <a:latin typeface="Malgun Gothic"/>
-              </a:defRPr>
-            </a:pPr>
-            <a:r>
-              <a:t>🏫 학생수 추이 분석</a:t>
-            </a:r>
-          </a:p>
-          <a:p>
-            <a:pPr>
-              <a:spcBef>
-                <a:spcPts val="1600"/>
-              </a:spcBef>
-              <a:defRPr sz="1300">
-                <a:solidFill>
-                  <a:srgbClr val="94A3B8"/>
-                </a:solidFill>
-                <a:latin typeface="Malgun Gothic"/>
-              </a:defRPr>
-            </a:pPr>
-            <a:r>
-              <a:t>2024~2026년 3개년 학교 학생수 모멘텀 검증</a:t>
-            </a:r>
-          </a:p>
-        </p:txBody>
-      </p:sp>
-      <p:sp>
-        <p:nvSpPr>
-          <p:cNvPr id="7" name="Rounded Rectangle 6"/>
-          <p:cNvSpPr/>
-          <p:nvPr/>
-        </p:nvSpPr>
-        <p:spPr>
-          <a:xfrm>
-            <a:off x="8823960" y="2011680"/>
-            <a:ext cx="2468880" cy="3840480"/>
-          </a:xfrm>
-          <a:prstGeom prst="roundRect">
-            <a:avLst/>
-          </a:prstGeom>
-          <a:solidFill>
-            <a:srgbClr val="1E293B"/>
-          </a:solidFill>
-          <a:ln w="25400">
-            <a:solidFill>
-              <a:srgbClr val="2ECC71"/>
-            </a:solidFill>
-          </a:ln>
-        </p:spPr>
-        <p:style>
-          <a:lnRef idx="1">
-            <a:schemeClr val="accent1"/>
-          </a:lnRef>
-          <a:fillRef idx="3">
-            <a:schemeClr val="accent1"/>
-          </a:fillRef>
-          <a:effectRef idx="2">
-            <a:schemeClr val="accent1"/>
-          </a:effectRef>
-          <a:fontRef idx="minor">
-            <a:schemeClr val="lt1"/>
-          </a:fontRef>
-        </p:style>
-        <p:txBody>
-          <a:bodyPr rtlCol="0" anchor="ctr" wrap="square" lIns="182880" rIns="182880" tIns="365760"/>
-          <a:lstStyle/>
-          <a:p>
-            <a:pPr algn="ctr">
-              <a:defRPr sz="1400" b="1">
-                <a:solidFill>
-                  <a:srgbClr val="2ECC71"/>
-                </a:solidFill>
-                <a:latin typeface="Malgun Gothic"/>
-              </a:defRPr>
-            </a:pPr>
-            <a:r>
-              <a:t>STEP 4</a:t>
-            </a:r>
-          </a:p>
-          <a:p>
-            <a:pPr>
-              <a:spcBef>
-                <a:spcPts val="1000"/>
-              </a:spcBef>
-              <a:defRPr sz="1700" b="1">
-                <a:solidFill>
-                  <a:srgbClr val="FFFFFF"/>
-                </a:solidFill>
-                <a:latin typeface="Malgun Gothic"/>
-              </a:defRPr>
-            </a:pPr>
-            <a:r>
-              <a:t>🏢 배후 수요 확정</a:t>
-            </a:r>
-          </a:p>
-          <a:p>
-            <a:pPr>
-              <a:spcBef>
-                <a:spcPts val="1600"/>
-              </a:spcBef>
-              <a:defRPr sz="1300">
-                <a:solidFill>
-                  <a:srgbClr val="94A3B8"/>
-                </a:solidFill>
-                <a:latin typeface="Malgun Gothic"/>
-              </a:defRPr>
-            </a:pPr>
-            <a:r>
-              <a:t>반경 3km 아파트 세대수 및 경쟁 학원가 밀집도 측정</a:t>
+              <a:t>• 수개월 걸리던 부동산 조사 및 입지 탐방을 '3초 만에 전국 210개 최적지 정밀 분석'으로 혁신.</a:t>
+            </a:r>
+            <a:br/>
+            <a:br/>
+            <a:r>
+              <a:t>• 기존 지점 3km 제외로 자기잠식을 막고, 🔥 1. 초희소형 입지 우선 진출로 시장 1위 빠른 독점.</a:t>
+            </a:r>
+            <a:br/>
+            <a:br/>
+            <a:r>
+              <a:t>• 🏛️ 4년제 대학교 인근 입지 검증을 병행하여 학원 사업 성장의 가장 큰 걸림돌인 '강사 구인 리스크' 원천 차단.</a:t>
+            </a:r>
+            <a:br/>
+            <a:br/>
+            <a:r>
+              <a:t>➔ 결론: 본 웹앱 시스템을 에이닷의 출점 의사결정 표준(Standard)으로 도입하여 실패 없는 기하급수적 성장을 견인할 것을 제언합니다.</a:t>
             </a:r>
           </a:p>
         </p:txBody>

</xml_diff>

<commit_message>
Update PPTX with 3 pillars of academy growth, Seoul Univ TOP 30 high schools, and 4-year univ dual values
</commit_message>
<xml_diff>
--- a/adot_expansion_presentation.pptx
+++ b/adot_expansion_presentation.pptx
@@ -10,6 +10,7 @@
     <p:sldId id="258" r:id="rId9"/>
     <p:sldId id="259" r:id="rId10"/>
     <p:sldId id="260" r:id="rId11"/>
+    <p:sldId id="261" r:id="rId12"/>
   </p:sldIdLst>
   <p:sldSz cx="12191695" cy="6858000" type="screen4x3"/>
   <p:notesSz cx="6858000" cy="9144000"/>
@@ -3185,7 +3186,7 @@
               </a:defRPr>
             </a:pPr>
             <a:r>
-              <a:t>🚀 이 웹앱이 에이닷(A.dot) 영어학원의 성장에 왜 필수적인가?</a:t>
+              <a:t>🎯 학원 성장의 3대 필수 조건과 데이터 상권 분석</a:t>
             </a:r>
           </a:p>
           <a:p>
@@ -3201,7 +3202,7 @@
               </a:defRPr>
             </a:pPr>
             <a:r>
-              <a:t>데이터 기반 실패 없는 출점 | 블루오션 시장 독점 | 강사 구인 리스크 제로화</a:t>
+              <a:t>콘텐츠 + 우수 강사진 + 스마트 상권 분석 웹앱 (서울대 TOP30 &amp; 4년제 대학)</a:t>
             </a:r>
           </a:p>
           <a:p>
@@ -3217,7 +3218,7 @@
               </a:defRPr>
             </a:pPr>
             <a:r>
-              <a:t>전국 네트워크 3km 반경 빅데이터 통합 시뮬레이션 시스템 보고서 | 2026. 08</a:t>
+              <a:t>에이닷 영어학원 지속 성장 &amp; 신규 출점 시뮬레이션 시스템 보고서 | 2026. 08</a:t>
             </a:r>
           </a:p>
         </p:txBody>
@@ -3314,7 +3315,7 @@
               </a:defRPr>
             </a:pPr>
             <a:r>
-              <a:t>에이닷(A.DOT) 영어학원 지속 성장 전략</a:t>
+              <a:t>에이닷(A.DOT) 영어학원 성장의 3대 필수 조건</a:t>
             </a:r>
           </a:p>
           <a:p>
@@ -3327,7 +3328,7 @@
               </a:defRPr>
             </a:pPr>
             <a:r>
-              <a:t>1. 에이닷 영어학원 성장을 이끄는 웹앱의 3대 핵심 가치</a:t>
+              <a:t>1. 학원 성장의 3대 필수 조건 (3 Pillars of Growth)</a:t>
             </a:r>
           </a:p>
         </p:txBody>
@@ -3341,6 +3342,174 @@
         <p:spPr>
           <a:xfrm>
             <a:off x="731520" y="1645920"/>
+            <a:ext cx="3383280" cy="4389120"/>
+          </a:xfrm>
+          <a:prstGeom prst="roundRect">
+            <a:avLst/>
+          </a:prstGeom>
+          <a:solidFill>
+            <a:srgbClr val="1E293B"/>
+          </a:solidFill>
+          <a:ln w="25400">
+            <a:solidFill>
+              <a:srgbClr val="F59E0B"/>
+            </a:solidFill>
+          </a:ln>
+        </p:spPr>
+        <p:style>
+          <a:lnRef idx="1">
+            <a:schemeClr val="accent1"/>
+          </a:lnRef>
+          <a:fillRef idx="3">
+            <a:schemeClr val="accent1"/>
+          </a:fillRef>
+          <a:effectRef idx="2">
+            <a:schemeClr val="accent1"/>
+          </a:effectRef>
+          <a:fontRef idx="minor">
+            <a:schemeClr val="lt1"/>
+          </a:fontRef>
+        </p:style>
+        <p:txBody>
+          <a:bodyPr rtlCol="0" anchor="ctr" wrap="square" lIns="274320" rIns="274320" tIns="365760"/>
+          <a:lstStyle/>
+          <a:p>
+            <a:pPr algn="ctr">
+              <a:defRPr sz="1800" b="1">
+                <a:solidFill>
+                  <a:srgbClr val="F59E0B"/>
+                </a:solidFill>
+                <a:latin typeface="Malgun Gothic"/>
+              </a:defRPr>
+            </a:pPr>
+            <a:r>
+              <a:t>📚 1. 콘텐츠</a:t>
+            </a:r>
+          </a:p>
+          <a:p>
+            <a:pPr>
+              <a:spcBef>
+                <a:spcPts val="1600"/>
+              </a:spcBef>
+              <a:defRPr sz="1400">
+                <a:solidFill>
+                  <a:srgbClr val="FFFFFF"/>
+                </a:solidFill>
+                <a:latin typeface="Malgun Gothic"/>
+              </a:defRPr>
+            </a:pPr>
+            <a:r>
+              <a:t>• 커리큘럼 및 교재</a:t>
+            </a:r>
+            <a:br/>
+            <a:r>
+              <a:t>• 자체 학습 시스템</a:t>
+            </a:r>
+            <a:br/>
+            <a:r>
+              <a:t>• 1:1 맞춤형 코칭 프로그램</a:t>
+            </a:r>
+            <a:br/>
+            <a:br/>
+            <a:r>
+              <a:t>👉 에이닷 독자 브랜드 가치</a:t>
+            </a:r>
+          </a:p>
+        </p:txBody>
+      </p:sp>
+      <p:sp>
+        <p:nvSpPr>
+          <p:cNvPr id="5" name="Rounded Rectangle 4"/>
+          <p:cNvSpPr/>
+          <p:nvPr/>
+        </p:nvSpPr>
+        <p:spPr>
+          <a:xfrm>
+            <a:off x="4343400" y="1645920"/>
+            <a:ext cx="3383280" cy="4389120"/>
+          </a:xfrm>
+          <a:prstGeom prst="roundRect">
+            <a:avLst/>
+          </a:prstGeom>
+          <a:solidFill>
+            <a:srgbClr val="1E293B"/>
+          </a:solidFill>
+          <a:ln w="25400">
+            <a:solidFill>
+              <a:srgbClr val="6366F1"/>
+            </a:solidFill>
+          </a:ln>
+        </p:spPr>
+        <p:style>
+          <a:lnRef idx="1">
+            <a:schemeClr val="accent1"/>
+          </a:lnRef>
+          <a:fillRef idx="3">
+            <a:schemeClr val="accent1"/>
+          </a:fillRef>
+          <a:effectRef idx="2">
+            <a:schemeClr val="accent1"/>
+          </a:effectRef>
+          <a:fontRef idx="minor">
+            <a:schemeClr val="lt1"/>
+          </a:fontRef>
+        </p:style>
+        <p:txBody>
+          <a:bodyPr rtlCol="0" anchor="ctr" wrap="square" lIns="274320" rIns="274320" tIns="365760"/>
+          <a:lstStyle/>
+          <a:p>
+            <a:pPr algn="ctr">
+              <a:defRPr sz="1800" b="1">
+                <a:solidFill>
+                  <a:srgbClr val="6366F1"/>
+                </a:solidFill>
+                <a:latin typeface="Malgun Gothic"/>
+              </a:defRPr>
+            </a:pPr>
+            <a:r>
+              <a:t>🎓 2. 우수 강사진</a:t>
+            </a:r>
+          </a:p>
+          <a:p>
+            <a:pPr>
+              <a:spcBef>
+                <a:spcPts val="1600"/>
+              </a:spcBef>
+              <a:defRPr sz="1400">
+                <a:solidFill>
+                  <a:srgbClr val="FFFFFF"/>
+                </a:solidFill>
+                <a:latin typeface="Malgun Gothic"/>
+              </a:defRPr>
+            </a:pPr>
+            <a:r>
+              <a:t>• 학생 지도 및 강의력</a:t>
+            </a:r>
+            <a:br/>
+            <a:r>
+              <a:t>• 동기부여 및 학습 관리</a:t>
+            </a:r>
+            <a:br/>
+            <a:r>
+              <a:t>• 4년제 대학 인재풀 연동</a:t>
+            </a:r>
+            <a:br/>
+            <a:br/>
+            <a:r>
+              <a:t>👉 성과 창출의 핵심 동력</a:t>
+            </a:r>
+          </a:p>
+        </p:txBody>
+      </p:sp>
+      <p:sp>
+        <p:nvSpPr>
+          <p:cNvPr id="6" name="Rounded Rectangle 5"/>
+          <p:cNvSpPr/>
+          <p:nvPr/>
+        </p:nvSpPr>
+        <p:spPr>
+          <a:xfrm>
+            <a:off x="7955280" y="1645920"/>
             <a:ext cx="3383280" cy="4389120"/>
           </a:xfrm>
           <a:prstGeom prst="roundRect">
@@ -3382,7 +3551,7 @@
               </a:defRPr>
             </a:pPr>
             <a:r>
-              <a:t>🎯 1. 실패 없는 출점 (Zero Risk)</a:t>
+              <a:t>🗺️ 3. 상권 분석</a:t>
             </a:r>
           </a:p>
           <a:p>
@@ -3398,173 +3567,20 @@
               </a:defRPr>
             </a:pPr>
             <a:r>
-              <a:t>• 기존의 '감'이나 부동산 의존 출점 탈피</a:t>
+              <a:t>• [핵심! 이 웹앱이 필요한 이유]</a:t>
             </a:r>
             <a:br/>
             <a:r>
-              <a:t>• 3개년(2024~2026) 학생수 추이 기반</a:t>
+              <a:t>• 수강생/잠재고객/학원수 정밀 분석</a:t>
             </a:r>
             <a:br/>
             <a:r>
-              <a:t>• 1.5만 세대+ 대단지 수급으로 100% 성공</a:t>
-            </a:r>
-          </a:p>
-        </p:txBody>
-      </p:sp>
-      <p:sp>
-        <p:nvSpPr>
-          <p:cNvPr id="5" name="Rounded Rectangle 4"/>
-          <p:cNvSpPr/>
-          <p:nvPr/>
-        </p:nvSpPr>
-        <p:spPr>
-          <a:xfrm>
-            <a:off x="4343400" y="1645920"/>
-            <a:ext cx="3383280" cy="4389120"/>
-          </a:xfrm>
-          <a:prstGeom prst="roundRect">
-            <a:avLst/>
-          </a:prstGeom>
-          <a:solidFill>
-            <a:srgbClr val="1E293B"/>
-          </a:solidFill>
-          <a:ln w="25400">
-            <a:solidFill>
-              <a:srgbClr val="F59E0B"/>
-            </a:solidFill>
-          </a:ln>
-        </p:spPr>
-        <p:style>
-          <a:lnRef idx="1">
-            <a:schemeClr val="accent1"/>
-          </a:lnRef>
-          <a:fillRef idx="3">
-            <a:schemeClr val="accent1"/>
-          </a:fillRef>
-          <a:effectRef idx="2">
-            <a:schemeClr val="accent1"/>
-          </a:effectRef>
-          <a:fontRef idx="minor">
-            <a:schemeClr val="lt1"/>
-          </a:fontRef>
-        </p:style>
-        <p:txBody>
-          <a:bodyPr rtlCol="0" anchor="ctr" wrap="square" lIns="274320" rIns="274320" tIns="365760"/>
-          <a:lstStyle/>
-          <a:p>
-            <a:pPr algn="ctr">
-              <a:defRPr sz="1800" b="1">
-                <a:solidFill>
-                  <a:srgbClr val="F59E0B"/>
-                </a:solidFill>
-                <a:latin typeface="Malgun Gothic"/>
-              </a:defRPr>
-            </a:pPr>
-            <a:r>
-              <a:t>🔥 2. 독점적 블루오션 선점</a:t>
-            </a:r>
-          </a:p>
-          <a:p>
-            <a:pPr>
-              <a:spcBef>
-                <a:spcPts val="1600"/>
-              </a:spcBef>
-              <a:defRPr sz="1400">
-                <a:solidFill>
-                  <a:srgbClr val="FFFFFF"/>
-                </a:solidFill>
-                <a:latin typeface="Malgun Gothic"/>
-              </a:defRPr>
-            </a:pPr>
-            <a:r>
-              <a:t>• 기존 지점 3km 이격 ➔ 자기잠식 0%</a:t>
+              <a:t>• 서울대 TOP30 및 학구열 판정</a:t>
             </a:r>
             <a:br/>
-            <a:r>
-              <a:t>• 경쟁 학원 50개 미만 지역 자동 발굴</a:t>
-            </a:r>
             <a:br/>
             <a:r>
-              <a:t>• 진출 즉시 신규 수강생 빠른 흡수</a:t>
-            </a:r>
-          </a:p>
-        </p:txBody>
-      </p:sp>
-      <p:sp>
-        <p:nvSpPr>
-          <p:cNvPr id="6" name="Rounded Rectangle 5"/>
-          <p:cNvSpPr/>
-          <p:nvPr/>
-        </p:nvSpPr>
-        <p:spPr>
-          <a:xfrm>
-            <a:off x="7955280" y="1645920"/>
-            <a:ext cx="3383280" cy="4389120"/>
-          </a:xfrm>
-          <a:prstGeom prst="roundRect">
-            <a:avLst/>
-          </a:prstGeom>
-          <a:solidFill>
-            <a:srgbClr val="1E293B"/>
-          </a:solidFill>
-          <a:ln w="25400">
-            <a:solidFill>
-              <a:srgbClr val="6366F1"/>
-            </a:solidFill>
-          </a:ln>
-        </p:spPr>
-        <p:style>
-          <a:lnRef idx="1">
-            <a:schemeClr val="accent1"/>
-          </a:lnRef>
-          <a:fillRef idx="3">
-            <a:schemeClr val="accent1"/>
-          </a:fillRef>
-          <a:effectRef idx="2">
-            <a:schemeClr val="accent1"/>
-          </a:effectRef>
-          <a:fontRef idx="minor">
-            <a:schemeClr val="lt1"/>
-          </a:fontRef>
-        </p:style>
-        <p:txBody>
-          <a:bodyPr rtlCol="0" anchor="ctr" wrap="square" lIns="274320" rIns="274320" tIns="365760"/>
-          <a:lstStyle/>
-          <a:p>
-            <a:pPr algn="ctr">
-              <a:defRPr sz="1800" b="1">
-                <a:solidFill>
-                  <a:srgbClr val="6366F1"/>
-                </a:solidFill>
-                <a:latin typeface="Malgun Gothic"/>
-              </a:defRPr>
-            </a:pPr>
-            <a:r>
-              <a:t>🏛️ 3. 강사 구인 리스크 제로화</a:t>
-            </a:r>
-          </a:p>
-          <a:p>
-            <a:pPr>
-              <a:spcBef>
-                <a:spcPts val="1600"/>
-              </a:spcBef>
-              <a:defRPr sz="1400">
-                <a:solidFill>
-                  <a:srgbClr val="FFFFFF"/>
-                </a:solidFill>
-                <a:latin typeface="Malgun Gothic"/>
-              </a:defRPr>
-            </a:pPr>
-            <a:r>
-              <a:t>• 학원 성장의 병목인 '우수 강사 구인' 해결</a:t>
-            </a:r>
-            <a:br/>
-            <a:r>
-              <a:t>• 4년제 대학교 인접 입지 정밀 분석</a:t>
-            </a:r>
-            <a:br/>
-            <a:r>
-              <a:t>• 명문대 대학생/대학원생 강사 인력 상시 수급</a:t>
+              <a:t>👉 실패 없는 출점의 완성</a:t>
             </a:r>
           </a:p>
         </p:txBody>
@@ -3661,7 +3677,7 @@
               </a:defRPr>
             </a:pPr>
             <a:r>
-              <a:t>에이닷(A.DOT) 영어학원 지속 성장 전략</a:t>
+              <a:t>에이닷(A.DOT) 영어학원 성장의 3대 필수 조건</a:t>
             </a:r>
           </a:p>
           <a:p>
@@ -3674,7 +3690,7 @@
               </a:defRPr>
             </a:pPr>
             <a:r>
-              <a:t>2. 성장을 가속화하는 🎯 RDB 추천입지 독점 모델</a:t>
+              <a:t>2. 상권 분석을 완벽하게 수행하는 4대 데이터 요소</a:t>
             </a:r>
           </a:p>
         </p:txBody>
@@ -3688,7 +3704,7 @@
         <p:spPr>
           <a:xfrm>
             <a:off x="731520" y="1645920"/>
-            <a:ext cx="3383280" cy="4389120"/>
+            <a:ext cx="5120640" cy="2011680"/>
           </a:xfrm>
           <a:prstGeom prst="roundRect">
             <a:avLst/>
@@ -3717,7 +3733,7 @@
           </a:fontRef>
         </p:style>
         <p:txBody>
-          <a:bodyPr rtlCol="0" anchor="ctr" wrap="square" lIns="274320" rIns="274320" tIns="365760"/>
+          <a:bodyPr rtlCol="0" anchor="ctr" wrap="square" lIns="274320" tIns="274320"/>
           <a:lstStyle/>
           <a:p>
             <a:pPr algn="ctr">
@@ -3729,15 +3745,15 @@
               </a:defRPr>
             </a:pPr>
             <a:r>
-              <a:t>🔥 1. 초희소형 (블루오션)</a:t>
+              <a:t>🏫 1. 학생수 추이</a:t>
             </a:r>
           </a:p>
           <a:p>
             <a:pPr>
               <a:spcBef>
-                <a:spcPts val="1600"/>
+                <a:spcPts val="1000"/>
               </a:spcBef>
-              <a:defRPr sz="1400">
+              <a:defRPr sz="1350">
                 <a:solidFill>
                   <a:srgbClr val="FFFFFF"/>
                 </a:solidFill>
@@ -3745,15 +3761,7 @@
               </a:defRPr>
             </a:pPr>
             <a:r>
-              <a:t>• 학원수 &lt; 50개 / 아파트 &gt; 1.5만 세대</a:t>
-            </a:r>
-            <a:br/>
-            <a:r>
-              <a:t>• 잠정고객 &gt; 300명 (중·고등 6,000명+)</a:t>
-            </a:r>
-            <a:br/>
-            <a:r>
-              <a:t>👉 경쟁 학원이 거의 없어 독점적 고수익 창출</a:t>
+              <a:t>2024~2026년 3개년 학교별 총원 및 학년별 유입/유출 추이 정밀 시각화</a:t>
             </a:r>
           </a:p>
         </p:txBody>
@@ -3766,8 +3774,8 @@
         </p:nvSpPr>
         <p:spPr>
           <a:xfrm>
-            <a:off x="4343400" y="1645920"/>
-            <a:ext cx="3383280" cy="4389120"/>
+            <a:off x="6172200" y="1645920"/>
+            <a:ext cx="5120640" cy="2011680"/>
           </a:xfrm>
           <a:prstGeom prst="roundRect">
             <a:avLst/>
@@ -3796,7 +3804,7 @@
           </a:fontRef>
         </p:style>
         <p:txBody>
-          <a:bodyPr rtlCol="0" anchor="ctr" wrap="square" lIns="274320" rIns="274320" tIns="365760"/>
+          <a:bodyPr rtlCol="0" anchor="ctr" wrap="square" lIns="274320" tIns="274320"/>
           <a:lstStyle/>
           <a:p>
             <a:pPr algn="ctr">
@@ -3808,15 +3816,15 @@
               </a:defRPr>
             </a:pPr>
             <a:r>
-              <a:t>⚡ 2. 세대밀집 (안정적 성장)</a:t>
+              <a:t>🎯 2. 잠재 고객수</a:t>
             </a:r>
           </a:p>
           <a:p>
             <a:pPr>
               <a:spcBef>
-                <a:spcPts val="1600"/>
+                <a:spcPts val="1000"/>
               </a:spcBef>
-              <a:defRPr sz="1400">
+              <a:defRPr sz="1350">
                 <a:solidFill>
                   <a:srgbClr val="FFFFFF"/>
                 </a:solidFill>
@@ -3824,15 +3832,7 @@
               </a:defRPr>
             </a:pPr>
             <a:r>
-              <a:t>• 아파트 &gt; 5.0만 세대 초밀집 타운</a:t>
-            </a:r>
-            <a:br/>
-            <a:r>
-              <a:t>• 학원수 &lt; 100개 / 잠정고객 &gt; 400명</a:t>
-            </a:r>
-            <a:br/>
-            <a:r>
-              <a:t>👉 풍부한 학령인구로 장기적 수강생 지속 확보</a:t>
+              <a:t>반경 3km 중·고등학생 총원의 5%를 잠정 고객수로 자동 계산 (유효 타겟)</a:t>
             </a:r>
           </a:p>
         </p:txBody>
@@ -3845,8 +3845,8 @@
         </p:nvSpPr>
         <p:spPr>
           <a:xfrm>
-            <a:off x="7955280" y="1645920"/>
-            <a:ext cx="3383280" cy="4389120"/>
+            <a:off x="731520" y="3931920"/>
+            <a:ext cx="5120640" cy="2011680"/>
           </a:xfrm>
           <a:prstGeom prst="roundRect">
             <a:avLst/>
@@ -3856,7 +3856,7 @@
           </a:solidFill>
           <a:ln w="25400">
             <a:solidFill>
-              <a:srgbClr val="FF6B81"/>
+              <a:srgbClr val="2ECC71"/>
             </a:solidFill>
           </a:ln>
         </p:spPr>
@@ -3875,27 +3875,27 @@
           </a:fontRef>
         </p:style>
         <p:txBody>
-          <a:bodyPr rtlCol="0" anchor="ctr" wrap="square" lIns="274320" rIns="274320" tIns="365760"/>
+          <a:bodyPr rtlCol="0" anchor="ctr" wrap="square" lIns="274320" tIns="274320"/>
           <a:lstStyle/>
           <a:p>
             <a:pPr algn="ctr">
               <a:defRPr sz="1800" b="1">
                 <a:solidFill>
-                  <a:srgbClr val="FF6B81"/>
+                  <a:srgbClr val="2ECC71"/>
                 </a:solidFill>
                 <a:latin typeface="Malgun Gothic"/>
               </a:defRPr>
             </a:pPr>
             <a:r>
-              <a:t>🖤 3. 메가타겟 (플래그십)</a:t>
+              <a:t>🏢 3. 아파트 세대수</a:t>
             </a:r>
           </a:p>
           <a:p>
             <a:pPr>
               <a:spcBef>
-                <a:spcPts val="1600"/>
+                <a:spcPts val="1000"/>
               </a:spcBef>
-              <a:defRPr sz="1400">
+              <a:defRPr sz="1350">
                 <a:solidFill>
                   <a:srgbClr val="FFFFFF"/>
                 </a:solidFill>
@@ -3903,15 +3903,78 @@
               </a:defRPr>
             </a:pPr>
             <a:r>
-              <a:t>• 잠정고객 &gt; 700명 (중·고등 1.4만명+)</a:t>
-            </a:r>
-            <a:br/>
-            <a:r>
-              <a:t>• 압도적 배후 인구의 초대형 지역</a:t>
-            </a:r>
-            <a:br/>
-            <a:r>
-              <a:t>👉 검빨(Black+Red) 테마 대형 플래그십 거점</a:t>
+              <a:t>반경 3km 내 대단지 주거 타운 세대수를 집계하여 탄탄한 배후 수요 측정</a:t>
+            </a:r>
+          </a:p>
+        </p:txBody>
+      </p:sp>
+      <p:sp>
+        <p:nvSpPr>
+          <p:cNvPr id="7" name="Rounded Rectangle 6"/>
+          <p:cNvSpPr/>
+          <p:nvPr/>
+        </p:nvSpPr>
+        <p:spPr>
+          <a:xfrm>
+            <a:off x="6172200" y="3931920"/>
+            <a:ext cx="5120640" cy="2011680"/>
+          </a:xfrm>
+          <a:prstGeom prst="roundRect">
+            <a:avLst/>
+          </a:prstGeom>
+          <a:solidFill>
+            <a:srgbClr val="1E293B"/>
+          </a:solidFill>
+          <a:ln w="25400">
+            <a:solidFill>
+              <a:srgbClr val="6366F1"/>
+            </a:solidFill>
+          </a:ln>
+        </p:spPr>
+        <p:style>
+          <a:lnRef idx="1">
+            <a:schemeClr val="accent1"/>
+          </a:lnRef>
+          <a:fillRef idx="3">
+            <a:schemeClr val="accent1"/>
+          </a:fillRef>
+          <a:effectRef idx="2">
+            <a:schemeClr val="accent1"/>
+          </a:effectRef>
+          <a:fontRef idx="minor">
+            <a:schemeClr val="lt1"/>
+          </a:fontRef>
+        </p:style>
+        <p:txBody>
+          <a:bodyPr rtlCol="0" anchor="ctr" wrap="square" lIns="274320" tIns="274320"/>
+          <a:lstStyle/>
+          <a:p>
+            <a:pPr algn="ctr">
+              <a:defRPr sz="1800" b="1">
+                <a:solidFill>
+                  <a:srgbClr val="6366F1"/>
+                </a:solidFill>
+                <a:latin typeface="Malgun Gothic"/>
+              </a:defRPr>
+            </a:pPr>
+            <a:r>
+              <a:t>📚 4. 학원수 (밀집도)</a:t>
+            </a:r>
+          </a:p>
+          <a:p>
+            <a:pPr>
+              <a:spcBef>
+                <a:spcPts val="1000"/>
+              </a:spcBef>
+              <a:defRPr sz="1350">
+                <a:solidFill>
+                  <a:srgbClr val="FFFFFF"/>
+                </a:solidFill>
+                <a:latin typeface="Malgun Gothic"/>
+              </a:defRPr>
+            </a:pPr>
+            <a:r>
+              <a:t>지번별 경쟁 학원수 분포 분석으로 독점적 초희소형(50개 미만) 시장 발굴</a:t>
             </a:r>
           </a:p>
         </p:txBody>
@@ -4008,7 +4071,7 @@
               </a:defRPr>
             </a:pPr>
             <a:r>
-              <a:t>에이닷(A.DOT) 영어학원 지속 성장 전략</a:t>
+              <a:t>에이닷(A.DOT) 영어학원 성장의 3대 필수 조건</a:t>
             </a:r>
           </a:p>
           <a:p>
@@ -4021,7 +4084,300 @@
               </a:defRPr>
             </a:pPr>
             <a:r>
-              <a:t>3. 학원 사업 성장의 최대 병목: '강사 구인 리스크' 완벽 해결</a:t>
+              <a:t>3. ⭐ 서울대 입결 TOP 30 고등학교 - 직관적 학구열 파악</a:t>
+            </a:r>
+          </a:p>
+        </p:txBody>
+      </p:sp>
+      <p:sp>
+        <p:nvSpPr>
+          <p:cNvPr id="4" name="Rounded Rectangle 3"/>
+          <p:cNvSpPr/>
+          <p:nvPr/>
+        </p:nvSpPr>
+        <p:spPr>
+          <a:xfrm>
+            <a:off x="731520" y="1645920"/>
+            <a:ext cx="5120640" cy="4389120"/>
+          </a:xfrm>
+          <a:prstGeom prst="roundRect">
+            <a:avLst/>
+          </a:prstGeom>
+          <a:solidFill>
+            <a:srgbClr val="1E293B"/>
+          </a:solidFill>
+          <a:ln w="25400">
+            <a:solidFill>
+              <a:srgbClr val="F59E0B"/>
+            </a:solidFill>
+          </a:ln>
+        </p:spPr>
+        <p:style>
+          <a:lnRef idx="1">
+            <a:schemeClr val="accent1"/>
+          </a:lnRef>
+          <a:fillRef idx="3">
+            <a:schemeClr val="accent1"/>
+          </a:fillRef>
+          <a:effectRef idx="2">
+            <a:schemeClr val="accent1"/>
+          </a:effectRef>
+          <a:fontRef idx="minor">
+            <a:schemeClr val="lt1"/>
+          </a:fontRef>
+        </p:style>
+        <p:txBody>
+          <a:bodyPr rtlCol="0" anchor="ctr" wrap="square" lIns="365760" tIns="365760"/>
+          <a:lstStyle/>
+          <a:p>
+            <a:pPr algn="ctr">
+              <a:defRPr sz="2000" b="1">
+                <a:solidFill>
+                  <a:srgbClr val="F59E0B"/>
+                </a:solidFill>
+                <a:latin typeface="Malgun Gothic"/>
+              </a:defRPr>
+            </a:pPr>
+            <a:r>
+              <a:t>⭐ 서울대 TOP 30 시각화의 의의</a:t>
+            </a:r>
+          </a:p>
+          <a:p>
+            <a:pPr>
+              <a:spcBef>
+                <a:spcPts val="1400"/>
+              </a:spcBef>
+              <a:defRPr sz="1350">
+                <a:solidFill>
+                  <a:srgbClr val="FFFFFF"/>
+                </a:solidFill>
+                <a:latin typeface="Malgun Gothic"/>
+              </a:defRPr>
+            </a:pPr>
+            <a:r>
+              <a:t>• 고등학교 중 '서울대 합격자수 상위 30개교' 마커 표시</a:t>
+            </a:r>
+            <a:br/>
+            <a:br/>
+            <a:r>
+              <a:t>• 지역 학구열의 직관적 파악:</a:t>
+            </a:r>
+            <a:br/>
+            <a:r>
+              <a:t>  - 지도에서 해당 지역에 TOP 30 고등학교가 위치해 있는지 한눈에 즉시 확인.</a:t>
+            </a:r>
+            <a:br/>
+            <a:br/>
+            <a:r>
+              <a:t>  - 학구열이 높은 지역일수록 학부모의 교육 투자 성향이 강하고 고난도 영어 코칭(에이닷) 수요가 폭발적임.</a:t>
+            </a:r>
+            <a:br/>
+            <a:br/>
+            <a:r>
+              <a:t>  - 프리미엄 입지 판정의 단초 역할 수행.</a:t>
+            </a:r>
+          </a:p>
+        </p:txBody>
+      </p:sp>
+      <p:sp>
+        <p:nvSpPr>
+          <p:cNvPr id="5" name="Rounded Rectangle 4"/>
+          <p:cNvSpPr/>
+          <p:nvPr/>
+        </p:nvSpPr>
+        <p:spPr>
+          <a:xfrm>
+            <a:off x="6217920" y="1645920"/>
+            <a:ext cx="5212080" cy="4389120"/>
+          </a:xfrm>
+          <a:prstGeom prst="roundRect">
+            <a:avLst/>
+          </a:prstGeom>
+          <a:solidFill>
+            <a:srgbClr val="1E293B"/>
+          </a:solidFill>
+          <a:ln w="25400">
+            <a:solidFill>
+              <a:srgbClr val="FF4757"/>
+            </a:solidFill>
+          </a:ln>
+        </p:spPr>
+        <p:style>
+          <a:lnRef idx="1">
+            <a:schemeClr val="accent1"/>
+          </a:lnRef>
+          <a:fillRef idx="3">
+            <a:schemeClr val="accent1"/>
+          </a:fillRef>
+          <a:effectRef idx="2">
+            <a:schemeClr val="accent1"/>
+          </a:effectRef>
+          <a:fontRef idx="minor">
+            <a:schemeClr val="lt1"/>
+          </a:fontRef>
+        </p:style>
+        <p:txBody>
+          <a:bodyPr rtlCol="0" anchor="ctr" wrap="square" lIns="365760" tIns="365760"/>
+          <a:lstStyle/>
+          <a:p>
+            <a:pPr algn="ctr">
+              <a:defRPr sz="2000" b="1">
+                <a:solidFill>
+                  <a:srgbClr val="FF4757"/>
+                </a:solidFill>
+                <a:latin typeface="Malgun Gothic"/>
+              </a:defRPr>
+            </a:pPr>
+            <a:r>
+              <a:t>📈 학구열과 에이닷 매출의 상관관계</a:t>
+            </a:r>
+          </a:p>
+          <a:p>
+            <a:pPr>
+              <a:spcBef>
+                <a:spcPts val="1400"/>
+              </a:spcBef>
+              <a:defRPr sz="1350">
+                <a:solidFill>
+                  <a:srgbClr val="FFFFFF"/>
+                </a:solidFill>
+                <a:latin typeface="Malgun Gothic"/>
+              </a:defRPr>
+            </a:pPr>
+            <a:r>
+              <a:t>1️⃣ 고학구열 지역의 수강생 LTV (평생가치) 증대:</a:t>
+            </a:r>
+            <a:br/>
+            <a:r>
+              <a:t>    내신 및 수능 대세를 이끄는 명문고 배후지로 장기 수강률 확보.</a:t>
+            </a:r>
+            <a:br/>
+            <a:br/>
+            <a:r>
+              <a:t>2️⃣ 마케팅 효율 및 입소문 확산 가속:</a:t>
+            </a:r>
+            <a:br/>
+            <a:r>
+              <a:t>    학부모 커뮤니티가 활성화되어 입소문을 통한 성과 전파가 매우 빠름.</a:t>
+            </a:r>
+            <a:br/>
+            <a:br/>
+            <a:r>
+              <a:t>3️⃣ 에이닷 브랜드 고급화 시너지:</a:t>
+            </a:r>
+            <a:br/>
+            <a:r>
+              <a:t>    명문고 상권 입점으로 지역 내 대표 영어학원으로 포지셔닝.</a:t>
+            </a:r>
+          </a:p>
+        </p:txBody>
+      </p:sp>
+    </p:spTree>
+  </p:cSld>
+  <p:clrMapOvr>
+    <a:masterClrMapping/>
+  </p:clrMapOvr>
+</p:sld>
+</file>
+
+<file path=ppt/slides/slide5.xml><?xml version="1.0" encoding="utf-8"?>
+<p:sld xmlns:a="http://schemas.openxmlformats.org/drawingml/2006/main" xmlns:p="http://schemas.openxmlformats.org/presentationml/2006/main" xmlns:r="http://schemas.openxmlformats.org/officeDocument/2006/relationships">
+  <p:cSld>
+    <p:spTree>
+      <p:nvGrpSpPr>
+        <p:cNvPr id="1" name=""/>
+        <p:cNvGrpSpPr/>
+        <p:nvPr/>
+      </p:nvGrpSpPr>
+      <p:grpSpPr/>
+      <p:sp>
+        <p:nvSpPr>
+          <p:cNvPr id="2" name="Rectangle 1"/>
+          <p:cNvSpPr/>
+          <p:nvPr/>
+        </p:nvSpPr>
+        <p:spPr>
+          <a:xfrm>
+            <a:off x="0" y="0"/>
+            <a:ext cx="12191695" cy="6858000"/>
+          </a:xfrm>
+          <a:prstGeom prst="rect">
+            <a:avLst/>
+          </a:prstGeom>
+          <a:solidFill>
+            <a:srgbClr val="0F172A"/>
+          </a:solidFill>
+          <a:ln>
+            <a:noFill/>
+          </a:ln>
+        </p:spPr>
+        <p:style>
+          <a:lnRef idx="1">
+            <a:schemeClr val="accent1"/>
+          </a:lnRef>
+          <a:fillRef idx="3">
+            <a:schemeClr val="accent1"/>
+          </a:fillRef>
+          <a:effectRef idx="2">
+            <a:schemeClr val="accent1"/>
+          </a:effectRef>
+          <a:fontRef idx="minor">
+            <a:schemeClr val="lt1"/>
+          </a:fontRef>
+        </p:style>
+        <p:txBody>
+          <a:bodyPr rtlCol="0" anchor="ctr"/>
+          <a:lstStyle/>
+          <a:p>
+            <a:pPr algn="ctr"/>
+          </a:p>
+        </p:txBody>
+      </p:sp>
+      <p:sp>
+        <p:nvSpPr>
+          <p:cNvPr id="3" name="TextBox 2"/>
+          <p:cNvSpPr txBox="1"/>
+          <p:nvPr/>
+        </p:nvSpPr>
+        <p:spPr>
+          <a:xfrm>
+            <a:off x="731520" y="365760"/>
+            <a:ext cx="10698480" cy="1005840"/>
+          </a:xfrm>
+          <a:prstGeom prst="rect">
+            <a:avLst/>
+          </a:prstGeom>
+          <a:noFill/>
+        </p:spPr>
+        <p:txBody>
+          <a:bodyPr wrap="square">
+            <a:spAutoFit/>
+          </a:bodyPr>
+          <a:lstStyle/>
+          <a:p>
+            <a:pPr>
+              <a:defRPr sz="1200" b="1">
+                <a:solidFill>
+                  <a:srgbClr val="FF4757"/>
+                </a:solidFill>
+                <a:latin typeface="Malgun Gothic"/>
+              </a:defRPr>
+            </a:pPr>
+            <a:r>
+              <a:t>에이닷(A.DOT) 영어학원 성장의 3대 필수 조건</a:t>
+            </a:r>
+          </a:p>
+          <a:p>
+            <a:pPr>
+              <a:defRPr sz="2500" b="1">
+                <a:solidFill>
+                  <a:srgbClr val="FFFFFF"/>
+                </a:solidFill>
+                <a:latin typeface="Malgun Gothic"/>
+              </a:defRPr>
+            </a:pPr>
+            <a:r>
+              <a:t>4. 🏛️ 4년제 대학교의 2대 가치: 학구열 판단 + 강사 수급 용이성</a:t>
             </a:r>
           </a:p>
         </p:txBody>
@@ -4076,15 +4432,15 @@
               </a:defRPr>
             </a:pPr>
             <a:r>
-              <a:t>🏛️ 4년제 대학교 입지 분석의 논리</a:t>
+              <a:t>🎓 1. 지역 학구열 지표로서의 가치</a:t>
             </a:r>
           </a:p>
           <a:p>
             <a:pPr>
               <a:spcBef>
-                <a:spcPts val="1400"/>
+                <a:spcPts val="1600"/>
               </a:spcBef>
-              <a:defRPr sz="1350">
+              <a:defRPr sz="1400">
                 <a:solidFill>
                   <a:srgbClr val="FFFFFF"/>
                 </a:solidFill>
@@ -4092,26 +4448,16 @@
               </a:defRPr>
             </a:pPr>
             <a:r>
-              <a:t>• 에이닷 성장의 핵심은 '우수한 강사진 수급'</a:t>
+              <a:t>• 4년제 대학교 입지 지역의 문화적 특징:</a:t>
+            </a:r>
+            <a:br/>
+            <a:r>
+              <a:t>  - 지적 분위기와 고학력 인구 비중이 높아 지역 전체의 학구열 수준 파악 가능.</a:t>
             </a:r>
             <a:br/>
             <a:br/>
             <a:r>
-              <a:t>• 주변 4년제 대학교 존재의 가치:</a:t>
-            </a:r>
-            <a:br/>
-            <a:r>
-              <a:t>  - 주요 대학생 및 대학원생 파트타임/전임 강사 인력풀이 항상 대기 중인 입지 확보.</a:t>
-            </a:r>
-            <a:br/>
-            <a:br/>
-            <a:r>
-              <a:t>  - 학원 개원 및 세 확장 시 강사 수급 난항으로 인한 개원 지연 및 운영 차질 방지.</a:t>
-            </a:r>
-            <a:br/>
-            <a:br/>
-            <a:r>
-              <a:t>  - 높은 수준의 지적 역량을 갖춘 강사 채용으로 학생/학부모 만족도 극대화.</a:t>
+              <a:t>  - 학부모들의 대학 입시 관심도가 높아 고급 인강/학원 코칭 수요가 지속적으로 높음.</a:t>
             </a:r>
           </a:p>
         </p:txBody>
@@ -4166,15 +4512,15 @@
               </a:defRPr>
             </a:pPr>
             <a:r>
-              <a:t>📈 지점 성장에 미치는 실질적 비즈니스 효과</a:t>
+              <a:t>🤝 2. 강사 구인 용이성 (수급 원활도)</a:t>
             </a:r>
           </a:p>
           <a:p>
             <a:pPr>
               <a:spcBef>
-                <a:spcPts val="1400"/>
+                <a:spcPts val="1600"/>
               </a:spcBef>
-              <a:defRPr sz="1350">
+              <a:defRPr sz="1400">
                 <a:solidFill>
                   <a:srgbClr val="FFFFFF"/>
                 </a:solidFill>
@@ -4182,29 +4528,16 @@
               </a:defRPr>
             </a:pPr>
             <a:r>
-              <a:t>1️⃣ 강사 구인 비용 &amp; 시간 절감 (Recruitment Cost 🔻):</a:t>
+              <a:t>• 우수한 강사 수급 리스크 원천 차단:</a:t>
             </a:r>
             <a:br/>
             <a:r>
-              <a:t>    대학 인접 입지로 구인 공고 시 빠르게 인재 채용 가능.</a:t>
+              <a:t>  - 명문 대학생 및 대학원생 파트타임/전임 강사를 가까운 인근에서 수월하게 구인.</a:t>
             </a:r>
             <a:br/>
             <a:br/>
             <a:r>
-              <a:t>2️⃣ 강사 퇴사 시 원활한 대타/신규 강사 교체:</a:t>
-            </a:r>
-            <a:br/>
-            <a:r>
-              <a:t>    인근 인력풀 확보로 수업 연속성 유지 및 이탈 방지.</a:t>
-            </a:r>
-            <a:br/>
-            <a:br/>
-            <a:r>
-              <a:t>3️⃣ 에이닷 브랜드의 지속적 세 확장 가속화:</a:t>
-            </a:r>
-            <a:br/>
-            <a:r>
-              <a:t>    강사 수급 걱정 없는 연쇄 출점으로 전국 네트워크 완성.</a:t>
+              <a:t>  - 강사 수급 난항으로 인한 개원 지연 및 휴원 위험을 방지하여 에이닷 네트워크 성장의 병목 해결.</a:t>
             </a:r>
           </a:p>
         </p:txBody>
@@ -4217,7 +4550,7 @@
 </p:sld>
 </file>
 
-<file path=ppt/slides/slide5.xml><?xml version="1.0" encoding="utf-8"?>
+<file path=ppt/slides/slide6.xml><?xml version="1.0" encoding="utf-8"?>
 <p:sld xmlns:a="http://schemas.openxmlformats.org/drawingml/2006/main" xmlns:p="http://schemas.openxmlformats.org/presentationml/2006/main" xmlns:r="http://schemas.openxmlformats.org/officeDocument/2006/relationships">
   <p:cSld>
     <p:spTree>
@@ -4301,7 +4634,7 @@
               </a:defRPr>
             </a:pPr>
             <a:r>
-              <a:t>에이닷(A.DOT) 영어학원 지속 성장 전략</a:t>
+              <a:t>에이닷(A.DOT) 영어학원 성장의 3대 필수 조건</a:t>
             </a:r>
           </a:p>
           <a:p>
@@ -4314,7 +4647,7 @@
               </a:defRPr>
             </a:pPr>
             <a:r>
-              <a:t>4. 비즈니스 임팩트 &amp; 경영진 최종 제언</a:t>
+              <a:t>5. 🎯 RDB 추천입지 모델 &amp; 경영진 최종 결론</a:t>
             </a:r>
           </a:p>
         </p:txBody>
@@ -4361,7 +4694,7 @@
           <a:lstStyle/>
           <a:p>
             <a:pPr algn="ctr">
-              <a:defRPr sz="2200" b="1">
+              <a:defRPr sz="2000" b="1">
                 <a:solidFill>
                   <a:srgbClr val="FF4757"/>
                 </a:solidFill>
@@ -4369,15 +4702,15 @@
               </a:defRPr>
             </a:pPr>
             <a:r>
-              <a:t>💡 본 웹앱은 에이닷 영어학원의 지속 가능한 성장을 위한 필수 데이터 엔진입니다.</a:t>
+              <a:t>💡 본 웹앱은 에이닷 성장의 3대 축 중 '상권 분석'의 최첨단 표준 시뮬레이터입니다.</a:t>
             </a:r>
           </a:p>
           <a:p>
             <a:pPr>
               <a:spcBef>
-                <a:spcPts val="2000"/>
+                <a:spcPts val="1600"/>
               </a:spcBef>
-              <a:defRPr sz="1500">
+              <a:defRPr sz="1450">
                 <a:solidFill>
                   <a:srgbClr val="FFFFFF"/>
                 </a:solidFill>
@@ -4385,22 +4718,17 @@
               </a:defRPr>
             </a:pPr>
             <a:r>
-              <a:t>• 수개월 걸리던 부동산 조사 및 입지 탐방을 '3초 만에 전국 210개 최적지 정밀 분석'으로 혁신.</a:t>
+              <a:t>• 콘텐츠와 우수 강사진이 준비되어 있다면, 마지막 성공 열쇠는 '상권 분석'입니다.</a:t>
             </a:r>
             <a:br/>
             <a:br/>
             <a:r>
-              <a:t>• 기존 지점 3km 제외로 자기잠식을 막고, 🔥 1. 초희소형 입지 우선 진출로 시장 1위 빠른 독점.</a:t>
+              <a:t>• 본 웹앱은 수강생/잠재고객/세대수/학원수 분석은 물론, ⭐ 서울대 TOP30과 🏛️ 4년제 대학교 데이터로 '학구열'과 '강사 구인 용이성'까지 직관적으로 판정합니다.</a:t>
             </a:r>
             <a:br/>
             <a:br/>
             <a:r>
-              <a:t>• 🏛️ 4년제 대학교 인근 입지 검증을 병행하여 학원 사업 성장의 가장 큰 걸림돌인 '강사 구인 리스크' 원천 차단.</a:t>
-            </a:r>
-            <a:br/>
-            <a:br/>
-            <a:r>
-              <a:t>➔ 결론: 본 웹앱 시스템을 에이닷의 출점 의사결정 표준(Standard)으로 도입하여 실패 없는 기하급수적 성장을 견인할 것을 제언합니다.</a:t>
+              <a:t>• 기존 지점 3km 이격으로 자기잠식을 막고 독점적 🔥 초희소형(학원&lt;50개) 지역을 우선 진출하여 실패 없는 전국 1위 성장을 견인할 것을 제언합니다.</a:t>
             </a:r>
           </a:p>
         </p:txBody>

</xml_diff>

<commit_message>
Update PPTX with 3 recommendation types strategy matrix and future data roadmap (purchasing power, college admissions, 3-year academy trends)
</commit_message>
<xml_diff>
--- a/adot_expansion_presentation.pptx
+++ b/adot_expansion_presentation.pptx
@@ -3174,11 +3174,11 @@
           </a:fontRef>
         </p:style>
         <p:txBody>
-          <a:bodyPr rtlCol="0" anchor="ctr" wrap="square" lIns="731520" tIns="822960"/>
+          <a:bodyPr rtlCol="0" anchor="ctr" wrap="square" lIns="731520" tIns="731520"/>
           <a:lstStyle/>
           <a:p>
             <a:pPr algn="ctr">
-              <a:defRPr sz="3200" b="1">
+              <a:defRPr sz="3000" b="1">
                 <a:solidFill>
                   <a:srgbClr val="FF4757"/>
                 </a:solidFill>
@@ -3186,15 +3186,15 @@
               </a:defRPr>
             </a:pPr>
             <a:r>
-              <a:t>🎯 학원 성장의 3대 필수 조건과 데이터 상권 분석</a:t>
+              <a:t>🎯 추천입지 유형별 맞춤 전략 &amp; 최적 입지 산출 모델</a:t>
             </a:r>
           </a:p>
           <a:p>
             <a:pPr>
               <a:spcBef>
-                <a:spcPts val="2000"/>
+                <a:spcPts val="1800"/>
               </a:spcBef>
-              <a:defRPr sz="2000" b="1">
+              <a:defRPr sz="1800" b="1">
                 <a:solidFill>
                   <a:srgbClr val="FFFFFF"/>
                 </a:solidFill>
@@ -3202,15 +3202,15 @@
               </a:defRPr>
             </a:pPr>
             <a:r>
-              <a:t>콘텐츠 + 우수 강사진 + 스마트 상권 분석 웹앱 (서울대 TOP30 &amp; 4년제 대학)</a:t>
+              <a:t>콘텐츠 + 우수 강사진 + 상권 분석 웹앱 (학원수 추이 / 아파트 매매가 구매력 / 대학 입결 데이터)</a:t>
             </a:r>
           </a:p>
           <a:p>
             <a:pPr>
               <a:spcBef>
-                <a:spcPts val="4500"/>
+                <a:spcPts val="4000"/>
               </a:spcBef>
-              <a:defRPr sz="1400">
+              <a:defRPr sz="1350">
                 <a:solidFill>
                   <a:srgbClr val="94A3B8"/>
                 </a:solidFill>
@@ -3690,7 +3690,633 @@
               </a:defRPr>
             </a:pPr>
             <a:r>
-              <a:t>2. 상권 분석을 완벽하게 수행하는 4대 데이터 요소</a:t>
+              <a:t>2. 🎯 추천입지 3개 유형 분류 &amp; 맞춤형 전략 진출 (한눈에 파악)</a:t>
+            </a:r>
+          </a:p>
+        </p:txBody>
+      </p:sp>
+      <p:sp>
+        <p:nvSpPr>
+          <p:cNvPr id="4" name="Rounded Rectangle 3"/>
+          <p:cNvSpPr/>
+          <p:nvPr/>
+        </p:nvSpPr>
+        <p:spPr>
+          <a:xfrm>
+            <a:off x="731520" y="1645920"/>
+            <a:ext cx="3383280" cy="4389120"/>
+          </a:xfrm>
+          <a:prstGeom prst="roundRect">
+            <a:avLst/>
+          </a:prstGeom>
+          <a:solidFill>
+            <a:srgbClr val="1E293B"/>
+          </a:solidFill>
+          <a:ln w="25400">
+            <a:solidFill>
+              <a:srgbClr val="FF4757"/>
+            </a:solidFill>
+          </a:ln>
+        </p:spPr>
+        <p:style>
+          <a:lnRef idx="1">
+            <a:schemeClr val="accent1"/>
+          </a:lnRef>
+          <a:fillRef idx="3">
+            <a:schemeClr val="accent1"/>
+          </a:fillRef>
+          <a:effectRef idx="2">
+            <a:schemeClr val="accent1"/>
+          </a:effectRef>
+          <a:fontRef idx="minor">
+            <a:schemeClr val="lt1"/>
+          </a:fontRef>
+        </p:style>
+        <p:txBody>
+          <a:bodyPr rtlCol="0" anchor="ctr" wrap="square" lIns="274320" rIns="274320" tIns="365760"/>
+          <a:lstStyle/>
+          <a:p>
+            <a:pPr algn="ctr">
+              <a:defRPr sz="1750" b="1">
+                <a:solidFill>
+                  <a:srgbClr val="FF4757"/>
+                </a:solidFill>
+                <a:latin typeface="Malgun Gothic"/>
+              </a:defRPr>
+            </a:pPr>
+            <a:r>
+              <a:t>🔥 1. 초희소형 (블루오션 독점)</a:t>
+            </a:r>
+          </a:p>
+          <a:p>
+            <a:pPr>
+              <a:spcBef>
+                <a:spcPts val="1600"/>
+              </a:spcBef>
+              <a:defRPr sz="1350">
+                <a:solidFill>
+                  <a:srgbClr val="FFFFFF"/>
+                </a:solidFill>
+                <a:latin typeface="Malgun Gothic"/>
+              </a:defRPr>
+            </a:pPr>
+            <a:r>
+              <a:t>• 학원수 &lt; 50개 / 아파트 &gt; 1.5만 세대</a:t>
+            </a:r>
+            <a:br/>
+            <a:r>
+              <a:t>• 잠정고객 &gt; 300명 (중·고등 6,000명+)</a:t>
+            </a:r>
+            <a:br/>
+            <a:r>
+              <a:t>👉 전략: 경쟁 부재 지역 우선 진출 ➔ 빠르게 시장 점유율 1위 독점</a:t>
+            </a:r>
+          </a:p>
+        </p:txBody>
+      </p:sp>
+      <p:sp>
+        <p:nvSpPr>
+          <p:cNvPr id="5" name="Rounded Rectangle 4"/>
+          <p:cNvSpPr/>
+          <p:nvPr/>
+        </p:nvSpPr>
+        <p:spPr>
+          <a:xfrm>
+            <a:off x="4343400" y="1645920"/>
+            <a:ext cx="3383280" cy="4389120"/>
+          </a:xfrm>
+          <a:prstGeom prst="roundRect">
+            <a:avLst/>
+          </a:prstGeom>
+          <a:solidFill>
+            <a:srgbClr val="1E293B"/>
+          </a:solidFill>
+          <a:ln w="25400">
+            <a:solidFill>
+              <a:srgbClr val="F59E0B"/>
+            </a:solidFill>
+          </a:ln>
+        </p:spPr>
+        <p:style>
+          <a:lnRef idx="1">
+            <a:schemeClr val="accent1"/>
+          </a:lnRef>
+          <a:fillRef idx="3">
+            <a:schemeClr val="accent1"/>
+          </a:fillRef>
+          <a:effectRef idx="2">
+            <a:schemeClr val="accent1"/>
+          </a:effectRef>
+          <a:fontRef idx="minor">
+            <a:schemeClr val="lt1"/>
+          </a:fontRef>
+        </p:style>
+        <p:txBody>
+          <a:bodyPr rtlCol="0" anchor="ctr" wrap="square" lIns="274320" rIns="274320" tIns="365760"/>
+          <a:lstStyle/>
+          <a:p>
+            <a:pPr algn="ctr">
+              <a:defRPr sz="1750" b="1">
+                <a:solidFill>
+                  <a:srgbClr val="F59E0B"/>
+                </a:solidFill>
+                <a:latin typeface="Malgun Gothic"/>
+              </a:defRPr>
+            </a:pPr>
+            <a:r>
+              <a:t>⚡ 2. 세대밀집 (안정적 거점)</a:t>
+            </a:r>
+          </a:p>
+          <a:p>
+            <a:pPr>
+              <a:spcBef>
+                <a:spcPts val="1600"/>
+              </a:spcBef>
+              <a:defRPr sz="1350">
+                <a:solidFill>
+                  <a:srgbClr val="FFFFFF"/>
+                </a:solidFill>
+                <a:latin typeface="Malgun Gothic"/>
+              </a:defRPr>
+            </a:pPr>
+            <a:r>
+              <a:t>• 아파트 &gt; 5.0만 세대 초밀집 타운</a:t>
+            </a:r>
+            <a:br/>
+            <a:r>
+              <a:t>• 학원수 &lt; 100개 / 잠정고객 &gt; 400명</a:t>
+            </a:r>
+            <a:br/>
+            <a:r>
+              <a:t>👉 전략: 풍부한 배후 세대 바탕 ➔ 장기 안정적 고수익 거점 확보</a:t>
+            </a:r>
+          </a:p>
+        </p:txBody>
+      </p:sp>
+      <p:sp>
+        <p:nvSpPr>
+          <p:cNvPr id="6" name="Rounded Rectangle 5"/>
+          <p:cNvSpPr/>
+          <p:nvPr/>
+        </p:nvSpPr>
+        <p:spPr>
+          <a:xfrm>
+            <a:off x="7955280" y="1645920"/>
+            <a:ext cx="3383280" cy="4389120"/>
+          </a:xfrm>
+          <a:prstGeom prst="roundRect">
+            <a:avLst/>
+          </a:prstGeom>
+          <a:solidFill>
+            <a:srgbClr val="1E293B"/>
+          </a:solidFill>
+          <a:ln w="25400">
+            <a:solidFill>
+              <a:srgbClr val="FF6B81"/>
+            </a:solidFill>
+          </a:ln>
+        </p:spPr>
+        <p:style>
+          <a:lnRef idx="1">
+            <a:schemeClr val="accent1"/>
+          </a:lnRef>
+          <a:fillRef idx="3">
+            <a:schemeClr val="accent1"/>
+          </a:fillRef>
+          <a:effectRef idx="2">
+            <a:schemeClr val="accent1"/>
+          </a:effectRef>
+          <a:fontRef idx="minor">
+            <a:schemeClr val="lt1"/>
+          </a:fontRef>
+        </p:style>
+        <p:txBody>
+          <a:bodyPr rtlCol="0" anchor="ctr" wrap="square" lIns="274320" rIns="274320" tIns="365760"/>
+          <a:lstStyle/>
+          <a:p>
+            <a:pPr algn="ctr">
+              <a:defRPr sz="1750" b="1">
+                <a:solidFill>
+                  <a:srgbClr val="FF6B81"/>
+                </a:solidFill>
+                <a:latin typeface="Malgun Gothic"/>
+              </a:defRPr>
+            </a:pPr>
+            <a:r>
+              <a:t>🖤 3. 메가타겟 (플래그십 거점)</a:t>
+            </a:r>
+          </a:p>
+          <a:p>
+            <a:pPr>
+              <a:spcBef>
+                <a:spcPts val="1600"/>
+              </a:spcBef>
+              <a:defRPr sz="1350">
+                <a:solidFill>
+                  <a:srgbClr val="FFFFFF"/>
+                </a:solidFill>
+                <a:latin typeface="Malgun Gothic"/>
+              </a:defRPr>
+            </a:pPr>
+            <a:r>
+              <a:t>• 잠정고객 &gt; 700명 (중·고등 1.4만명+)</a:t>
+            </a:r>
+            <a:br/>
+            <a:r>
+              <a:t>• 검빨(Black+Red) 전용 글로우 테마</a:t>
+            </a:r>
+            <a:br/>
+            <a:r>
+              <a:t>👉 전략: 초대형 학령 인구 상권 ➔ 브랜드 대형 플래그십 출점</a:t>
+            </a:r>
+          </a:p>
+        </p:txBody>
+      </p:sp>
+    </p:spTree>
+  </p:cSld>
+  <p:clrMapOvr>
+    <a:masterClrMapping/>
+  </p:clrMapOvr>
+</p:sld>
+</file>
+
+<file path=ppt/slides/slide4.xml><?xml version="1.0" encoding="utf-8"?>
+<p:sld xmlns:a="http://schemas.openxmlformats.org/drawingml/2006/main" xmlns:p="http://schemas.openxmlformats.org/presentationml/2006/main" xmlns:r="http://schemas.openxmlformats.org/officeDocument/2006/relationships">
+  <p:cSld>
+    <p:spTree>
+      <p:nvGrpSpPr>
+        <p:cNvPr id="1" name=""/>
+        <p:cNvGrpSpPr/>
+        <p:nvPr/>
+      </p:nvGrpSpPr>
+      <p:grpSpPr/>
+      <p:sp>
+        <p:nvSpPr>
+          <p:cNvPr id="2" name="Rectangle 1"/>
+          <p:cNvSpPr/>
+          <p:nvPr/>
+        </p:nvSpPr>
+        <p:spPr>
+          <a:xfrm>
+            <a:off x="0" y="0"/>
+            <a:ext cx="12191695" cy="6858000"/>
+          </a:xfrm>
+          <a:prstGeom prst="rect">
+            <a:avLst/>
+          </a:prstGeom>
+          <a:solidFill>
+            <a:srgbClr val="0F172A"/>
+          </a:solidFill>
+          <a:ln>
+            <a:noFill/>
+          </a:ln>
+        </p:spPr>
+        <p:style>
+          <a:lnRef idx="1">
+            <a:schemeClr val="accent1"/>
+          </a:lnRef>
+          <a:fillRef idx="3">
+            <a:schemeClr val="accent1"/>
+          </a:fillRef>
+          <a:effectRef idx="2">
+            <a:schemeClr val="accent1"/>
+          </a:effectRef>
+          <a:fontRef idx="minor">
+            <a:schemeClr val="lt1"/>
+          </a:fontRef>
+        </p:style>
+        <p:txBody>
+          <a:bodyPr rtlCol="0" anchor="ctr"/>
+          <a:lstStyle/>
+          <a:p>
+            <a:pPr algn="ctr"/>
+          </a:p>
+        </p:txBody>
+      </p:sp>
+      <p:sp>
+        <p:nvSpPr>
+          <p:cNvPr id="3" name="TextBox 2"/>
+          <p:cNvSpPr txBox="1"/>
+          <p:nvPr/>
+        </p:nvSpPr>
+        <p:spPr>
+          <a:xfrm>
+            <a:off x="731520" y="365760"/>
+            <a:ext cx="10698480" cy="1005840"/>
+          </a:xfrm>
+          <a:prstGeom prst="rect">
+            <a:avLst/>
+          </a:prstGeom>
+          <a:noFill/>
+        </p:spPr>
+        <p:txBody>
+          <a:bodyPr wrap="square">
+            <a:spAutoFit/>
+          </a:bodyPr>
+          <a:lstStyle/>
+          <a:p>
+            <a:pPr>
+              <a:defRPr sz="1200" b="1">
+                <a:solidFill>
+                  <a:srgbClr val="FF4757"/>
+                </a:solidFill>
+                <a:latin typeface="Malgun Gothic"/>
+              </a:defRPr>
+            </a:pPr>
+            <a:r>
+              <a:t>에이닷(A.DOT) 영어학원 성장의 3대 필수 조건</a:t>
+            </a:r>
+          </a:p>
+          <a:p>
+            <a:pPr>
+              <a:defRPr sz="2500" b="1">
+                <a:solidFill>
+                  <a:srgbClr val="FFFFFF"/>
+                </a:solidFill>
+                <a:latin typeface="Malgun Gothic"/>
+              </a:defRPr>
+            </a:pPr>
+            <a:r>
+              <a:t>3. ⭐ 서울대 TOP30 &amp; 🏛️ 4년제 대학 (학구열 + 강사 수급)</a:t>
+            </a:r>
+          </a:p>
+        </p:txBody>
+      </p:sp>
+      <p:sp>
+        <p:nvSpPr>
+          <p:cNvPr id="4" name="Rounded Rectangle 3"/>
+          <p:cNvSpPr/>
+          <p:nvPr/>
+        </p:nvSpPr>
+        <p:spPr>
+          <a:xfrm>
+            <a:off x="731520" y="1645920"/>
+            <a:ext cx="5120640" cy="4389120"/>
+          </a:xfrm>
+          <a:prstGeom prst="roundRect">
+            <a:avLst/>
+          </a:prstGeom>
+          <a:solidFill>
+            <a:srgbClr val="1E293B"/>
+          </a:solidFill>
+          <a:ln w="25400">
+            <a:solidFill>
+              <a:srgbClr val="F59E0B"/>
+            </a:solidFill>
+          </a:ln>
+        </p:spPr>
+        <p:style>
+          <a:lnRef idx="1">
+            <a:schemeClr val="accent1"/>
+          </a:lnRef>
+          <a:fillRef idx="3">
+            <a:schemeClr val="accent1"/>
+          </a:fillRef>
+          <a:effectRef idx="2">
+            <a:schemeClr val="accent1"/>
+          </a:effectRef>
+          <a:fontRef idx="minor">
+            <a:schemeClr val="lt1"/>
+          </a:fontRef>
+        </p:style>
+        <p:txBody>
+          <a:bodyPr rtlCol="0" anchor="ctr" wrap="square" lIns="365760" tIns="365760"/>
+          <a:lstStyle/>
+          <a:p>
+            <a:pPr algn="ctr">
+              <a:defRPr sz="1900" b="1">
+                <a:solidFill>
+                  <a:srgbClr val="F59E0B"/>
+                </a:solidFill>
+                <a:latin typeface="Malgun Gothic"/>
+              </a:defRPr>
+            </a:pPr>
+            <a:r>
+              <a:t>⭐ 서울대 입결 TOP 30 시각화</a:t>
+            </a:r>
+          </a:p>
+          <a:p>
+            <a:pPr>
+              <a:spcBef>
+                <a:spcPts val="1200"/>
+              </a:spcBef>
+              <a:defRPr sz="1300">
+                <a:solidFill>
+                  <a:srgbClr val="FFFFFF"/>
+                </a:solidFill>
+                <a:latin typeface="Malgun Gothic"/>
+              </a:defRPr>
+            </a:pPr>
+            <a:r>
+              <a:t>• 2026년 서울대 합격자 상위 30개 고등학교 마커 배치</a:t>
+            </a:r>
+            <a:br/>
+            <a:br/>
+            <a:r>
+              <a:t>• 직관적 학구열 파악:</a:t>
+            </a:r>
+            <a:br/>
+            <a:r>
+              <a:t>  - 지도에서 TOP 30 고교 위치를 한눈에 파악하여 해당 상권의 학구열 수준 판정.</a:t>
+            </a:r>
+            <a:br/>
+            <a:br/>
+            <a:r>
+              <a:t>  - 학구열이 높은 상권일수록 에이닷 1:1 고난도 코칭 수요가 폭발하며 수강생 LTV 극대화.</a:t>
+            </a:r>
+          </a:p>
+        </p:txBody>
+      </p:sp>
+      <p:sp>
+        <p:nvSpPr>
+          <p:cNvPr id="5" name="Rounded Rectangle 4"/>
+          <p:cNvSpPr/>
+          <p:nvPr/>
+        </p:nvSpPr>
+        <p:spPr>
+          <a:xfrm>
+            <a:off x="6217920" y="1645920"/>
+            <a:ext cx="5212080" cy="4389120"/>
+          </a:xfrm>
+          <a:prstGeom prst="roundRect">
+            <a:avLst/>
+          </a:prstGeom>
+          <a:solidFill>
+            <a:srgbClr val="1E293B"/>
+          </a:solidFill>
+          <a:ln w="25400">
+            <a:solidFill>
+              <a:srgbClr val="6366F1"/>
+            </a:solidFill>
+          </a:ln>
+        </p:spPr>
+        <p:style>
+          <a:lnRef idx="1">
+            <a:schemeClr val="accent1"/>
+          </a:lnRef>
+          <a:fillRef idx="3">
+            <a:schemeClr val="accent1"/>
+          </a:fillRef>
+          <a:effectRef idx="2">
+            <a:schemeClr val="accent1"/>
+          </a:effectRef>
+          <a:fontRef idx="minor">
+            <a:schemeClr val="lt1"/>
+          </a:fontRef>
+        </p:style>
+        <p:txBody>
+          <a:bodyPr rtlCol="0" anchor="ctr" wrap="square" lIns="365760" tIns="365760"/>
+          <a:lstStyle/>
+          <a:p>
+            <a:pPr algn="ctr">
+              <a:defRPr sz="1900" b="1">
+                <a:solidFill>
+                  <a:srgbClr val="6366F1"/>
+                </a:solidFill>
+                <a:latin typeface="Malgun Gothic"/>
+              </a:defRPr>
+            </a:pPr>
+            <a:r>
+              <a:t>🏛️ 4년제 대학교 2대 핵심 가치</a:t>
+            </a:r>
+          </a:p>
+          <a:p>
+            <a:pPr>
+              <a:spcBef>
+                <a:spcPts val="1200"/>
+              </a:spcBef>
+              <a:defRPr sz="1300">
+                <a:solidFill>
+                  <a:srgbClr val="FFFFFF"/>
+                </a:solidFill>
+                <a:latin typeface="Malgun Gothic"/>
+              </a:defRPr>
+            </a:pPr>
+            <a:r>
+              <a:t>1️⃣ 지역 전체의 지적 분위기 &amp; 학구열 측정 지표</a:t>
+            </a:r>
+            <a:br/>
+            <a:br/>
+            <a:r>
+              <a:t>2️⃣ 명문 대학생/대학원생 강사 수급 용이성:</a:t>
+            </a:r>
+            <a:br/>
+            <a:r>
+              <a:t>    - 가까운 인근에서 우수 강사를 빠르게 구인.</a:t>
+            </a:r>
+            <a:br/>
+            <a:r>
+              <a:t>    - 개원 초기 '강사 구인 리스크'를 제로화하여 지점 운영의 안정성 및 매출 성장 보장.</a:t>
+            </a:r>
+          </a:p>
+        </p:txBody>
+      </p:sp>
+    </p:spTree>
+  </p:cSld>
+  <p:clrMapOvr>
+    <a:masterClrMapping/>
+  </p:clrMapOvr>
+</p:sld>
+</file>
+
+<file path=ppt/slides/slide5.xml><?xml version="1.0" encoding="utf-8"?>
+<p:sld xmlns:a="http://schemas.openxmlformats.org/drawingml/2006/main" xmlns:p="http://schemas.openxmlformats.org/presentationml/2006/main" xmlns:r="http://schemas.openxmlformats.org/officeDocument/2006/relationships">
+  <p:cSld>
+    <p:spTree>
+      <p:nvGrpSpPr>
+        <p:cNvPr id="1" name=""/>
+        <p:cNvGrpSpPr/>
+        <p:nvPr/>
+      </p:nvGrpSpPr>
+      <p:grpSpPr/>
+      <p:sp>
+        <p:nvSpPr>
+          <p:cNvPr id="2" name="Rectangle 1"/>
+          <p:cNvSpPr/>
+          <p:nvPr/>
+        </p:nvSpPr>
+        <p:spPr>
+          <a:xfrm>
+            <a:off x="0" y="0"/>
+            <a:ext cx="12191695" cy="6858000"/>
+          </a:xfrm>
+          <a:prstGeom prst="rect">
+            <a:avLst/>
+          </a:prstGeom>
+          <a:solidFill>
+            <a:srgbClr val="0F172A"/>
+          </a:solidFill>
+          <a:ln>
+            <a:noFill/>
+          </a:ln>
+        </p:spPr>
+        <p:style>
+          <a:lnRef idx="1">
+            <a:schemeClr val="accent1"/>
+          </a:lnRef>
+          <a:fillRef idx="3">
+            <a:schemeClr val="accent1"/>
+          </a:fillRef>
+          <a:effectRef idx="2">
+            <a:schemeClr val="accent1"/>
+          </a:effectRef>
+          <a:fontRef idx="minor">
+            <a:schemeClr val="lt1"/>
+          </a:fontRef>
+        </p:style>
+        <p:txBody>
+          <a:bodyPr rtlCol="0" anchor="ctr"/>
+          <a:lstStyle/>
+          <a:p>
+            <a:pPr algn="ctr"/>
+          </a:p>
+        </p:txBody>
+      </p:sp>
+      <p:sp>
+        <p:nvSpPr>
+          <p:cNvPr id="3" name="TextBox 2"/>
+          <p:cNvSpPr txBox="1"/>
+          <p:nvPr/>
+        </p:nvSpPr>
+        <p:spPr>
+          <a:xfrm>
+            <a:off x="731520" y="365760"/>
+            <a:ext cx="10698480" cy="1005840"/>
+          </a:xfrm>
+          <a:prstGeom prst="rect">
+            <a:avLst/>
+          </a:prstGeom>
+          <a:noFill/>
+        </p:spPr>
+        <p:txBody>
+          <a:bodyPr wrap="square">
+            <a:spAutoFit/>
+          </a:bodyPr>
+          <a:lstStyle/>
+          <a:p>
+            <a:pPr>
+              <a:defRPr sz="1200" b="1">
+                <a:solidFill>
+                  <a:srgbClr val="FF4757"/>
+                </a:solidFill>
+                <a:latin typeface="Malgun Gothic"/>
+              </a:defRPr>
+            </a:pPr>
+            <a:r>
+              <a:t>에이닷(A.DOT) 영어학원 성장의 3대 필수 조건</a:t>
+            </a:r>
+          </a:p>
+          <a:p>
+            <a:pPr>
+              <a:defRPr sz="2500" b="1">
+                <a:solidFill>
+                  <a:srgbClr val="FFFFFF"/>
+                </a:solidFill>
+                <a:latin typeface="Malgun Gothic"/>
+              </a:defRPr>
+            </a:pPr>
+            <a:r>
+              <a:t>4. 🚀 미래 고도화 로드맵: 에이닷 최적 입지조건 자동 산출</a:t>
             </a:r>
           </a:p>
         </p:txBody>
@@ -3745,7 +4371,7 @@
               </a:defRPr>
             </a:pPr>
             <a:r>
-              <a:t>🏫 1. 학생수 추이</a:t>
+              <a:t>📈 3개년 학원수 추이</a:t>
             </a:r>
           </a:p>
           <a:p>
@@ -3761,7 +4387,7 @@
               </a:defRPr>
             </a:pPr>
             <a:r>
-              <a:t>2024~2026년 3개년 학교별 총원 및 학년별 유입/유출 추이 정밀 시각화</a:t>
+              <a:t>학원 시장의 성숙도 및 포화 모멘텀 분석</a:t>
             </a:r>
           </a:p>
         </p:txBody>
@@ -3816,7 +4442,7 @@
               </a:defRPr>
             </a:pPr>
             <a:r>
-              <a:t>🎯 2. 잠재 고객수</a:t>
+              <a:t>🏢 아파트 매매가 데이터</a:t>
             </a:r>
           </a:p>
           <a:p>
@@ -3832,7 +4458,7 @@
               </a:defRPr>
             </a:pPr>
             <a:r>
-              <a:t>반경 3km 중·고등학생 총원의 5%를 잠정 고객수로 자동 계산 (유효 타겟)</a:t>
+              <a:t>지역 가구 소득 수준 및 교육비 구매력(Purchasing Power) 파악</a:t>
             </a:r>
           </a:p>
         </p:txBody>
@@ -3846,6 +4472,77 @@
         <p:spPr>
           <a:xfrm>
             <a:off x="731520" y="3931920"/>
+            <a:ext cx="5120640" cy="2011680"/>
+          </a:xfrm>
+          <a:prstGeom prst="roundRect">
+            <a:avLst/>
+          </a:prstGeom>
+          <a:solidFill>
+            <a:srgbClr val="1E293B"/>
+          </a:solidFill>
+          <a:ln w="25400">
+            <a:solidFill>
+              <a:srgbClr val="6366F1"/>
+            </a:solidFill>
+          </a:ln>
+        </p:spPr>
+        <p:style>
+          <a:lnRef idx="1">
+            <a:schemeClr val="accent1"/>
+          </a:lnRef>
+          <a:fillRef idx="3">
+            <a:schemeClr val="accent1"/>
+          </a:fillRef>
+          <a:effectRef idx="2">
+            <a:schemeClr val="accent1"/>
+          </a:effectRef>
+          <a:fontRef idx="minor">
+            <a:schemeClr val="lt1"/>
+          </a:fontRef>
+        </p:style>
+        <p:txBody>
+          <a:bodyPr rtlCol="0" anchor="ctr" wrap="square" lIns="274320" tIns="274320"/>
+          <a:lstStyle/>
+          <a:p>
+            <a:pPr algn="ctr">
+              <a:defRPr sz="1800" b="1">
+                <a:solidFill>
+                  <a:srgbClr val="6366F1"/>
+                </a:solidFill>
+                <a:latin typeface="Malgun Gothic"/>
+              </a:defRPr>
+            </a:pPr>
+            <a:r>
+              <a:t>🎓 4년제 대학 수시/수능 입결</a:t>
+            </a:r>
+          </a:p>
+          <a:p>
+            <a:pPr>
+              <a:spcBef>
+                <a:spcPts val="1000"/>
+              </a:spcBef>
+              <a:defRPr sz="1350">
+                <a:solidFill>
+                  <a:srgbClr val="FFFFFF"/>
+                </a:solidFill>
+                <a:latin typeface="Malgun Gothic"/>
+              </a:defRPr>
+            </a:pPr>
+            <a:r>
+              <a:t>대학 입결 수준 기반 학구열 및 강사 품질 정밀 평가</a:t>
+            </a:r>
+          </a:p>
+        </p:txBody>
+      </p:sp>
+      <p:sp>
+        <p:nvSpPr>
+          <p:cNvPr id="7" name="Rounded Rectangle 6"/>
+          <p:cNvSpPr/>
+          <p:nvPr/>
+        </p:nvSpPr>
+        <p:spPr>
+          <a:xfrm>
+            <a:off x="6172200" y="3931920"/>
             <a:ext cx="5120640" cy="2011680"/>
           </a:xfrm>
           <a:prstGeom prst="roundRect">
@@ -3887,7 +4584,7 @@
               </a:defRPr>
             </a:pPr>
             <a:r>
-              <a:t>🏢 3. 아파트 세대수</a:t>
+              <a:t>💡 최적 입지조건 자동 산출</a:t>
             </a:r>
           </a:p>
           <a:p>
@@ -3903,641 +4600,7 @@
               </a:defRPr>
             </a:pPr>
             <a:r>
-              <a:t>반경 3km 내 대단지 주거 타운 세대수를 집계하여 탄탄한 배후 수요 측정</a:t>
-            </a:r>
-          </a:p>
-        </p:txBody>
-      </p:sp>
-      <p:sp>
-        <p:nvSpPr>
-          <p:cNvPr id="7" name="Rounded Rectangle 6"/>
-          <p:cNvSpPr/>
-          <p:nvPr/>
-        </p:nvSpPr>
-        <p:spPr>
-          <a:xfrm>
-            <a:off x="6172200" y="3931920"/>
-            <a:ext cx="5120640" cy="2011680"/>
-          </a:xfrm>
-          <a:prstGeom prst="roundRect">
-            <a:avLst/>
-          </a:prstGeom>
-          <a:solidFill>
-            <a:srgbClr val="1E293B"/>
-          </a:solidFill>
-          <a:ln w="25400">
-            <a:solidFill>
-              <a:srgbClr val="6366F1"/>
-            </a:solidFill>
-          </a:ln>
-        </p:spPr>
-        <p:style>
-          <a:lnRef idx="1">
-            <a:schemeClr val="accent1"/>
-          </a:lnRef>
-          <a:fillRef idx="3">
-            <a:schemeClr val="accent1"/>
-          </a:fillRef>
-          <a:effectRef idx="2">
-            <a:schemeClr val="accent1"/>
-          </a:effectRef>
-          <a:fontRef idx="minor">
-            <a:schemeClr val="lt1"/>
-          </a:fontRef>
-        </p:style>
-        <p:txBody>
-          <a:bodyPr rtlCol="0" anchor="ctr" wrap="square" lIns="274320" tIns="274320"/>
-          <a:lstStyle/>
-          <a:p>
-            <a:pPr algn="ctr">
-              <a:defRPr sz="1800" b="1">
-                <a:solidFill>
-                  <a:srgbClr val="6366F1"/>
-                </a:solidFill>
-                <a:latin typeface="Malgun Gothic"/>
-              </a:defRPr>
-            </a:pPr>
-            <a:r>
-              <a:t>📚 4. 학원수 (밀집도)</a:t>
-            </a:r>
-          </a:p>
-          <a:p>
-            <a:pPr>
-              <a:spcBef>
-                <a:spcPts val="1000"/>
-              </a:spcBef>
-              <a:defRPr sz="1350">
-                <a:solidFill>
-                  <a:srgbClr val="FFFFFF"/>
-                </a:solidFill>
-                <a:latin typeface="Malgun Gothic"/>
-              </a:defRPr>
-            </a:pPr>
-            <a:r>
-              <a:t>지번별 경쟁 학원수 분포 분석으로 독점적 초희소형(50개 미만) 시장 발굴</a:t>
-            </a:r>
-          </a:p>
-        </p:txBody>
-      </p:sp>
-    </p:spTree>
-  </p:cSld>
-  <p:clrMapOvr>
-    <a:masterClrMapping/>
-  </p:clrMapOvr>
-</p:sld>
-</file>
-
-<file path=ppt/slides/slide4.xml><?xml version="1.0" encoding="utf-8"?>
-<p:sld xmlns:a="http://schemas.openxmlformats.org/drawingml/2006/main" xmlns:p="http://schemas.openxmlformats.org/presentationml/2006/main" xmlns:r="http://schemas.openxmlformats.org/officeDocument/2006/relationships">
-  <p:cSld>
-    <p:spTree>
-      <p:nvGrpSpPr>
-        <p:cNvPr id="1" name=""/>
-        <p:cNvGrpSpPr/>
-        <p:nvPr/>
-      </p:nvGrpSpPr>
-      <p:grpSpPr/>
-      <p:sp>
-        <p:nvSpPr>
-          <p:cNvPr id="2" name="Rectangle 1"/>
-          <p:cNvSpPr/>
-          <p:nvPr/>
-        </p:nvSpPr>
-        <p:spPr>
-          <a:xfrm>
-            <a:off x="0" y="0"/>
-            <a:ext cx="12191695" cy="6858000"/>
-          </a:xfrm>
-          <a:prstGeom prst="rect">
-            <a:avLst/>
-          </a:prstGeom>
-          <a:solidFill>
-            <a:srgbClr val="0F172A"/>
-          </a:solidFill>
-          <a:ln>
-            <a:noFill/>
-          </a:ln>
-        </p:spPr>
-        <p:style>
-          <a:lnRef idx="1">
-            <a:schemeClr val="accent1"/>
-          </a:lnRef>
-          <a:fillRef idx="3">
-            <a:schemeClr val="accent1"/>
-          </a:fillRef>
-          <a:effectRef idx="2">
-            <a:schemeClr val="accent1"/>
-          </a:effectRef>
-          <a:fontRef idx="minor">
-            <a:schemeClr val="lt1"/>
-          </a:fontRef>
-        </p:style>
-        <p:txBody>
-          <a:bodyPr rtlCol="0" anchor="ctr"/>
-          <a:lstStyle/>
-          <a:p>
-            <a:pPr algn="ctr"/>
-          </a:p>
-        </p:txBody>
-      </p:sp>
-      <p:sp>
-        <p:nvSpPr>
-          <p:cNvPr id="3" name="TextBox 2"/>
-          <p:cNvSpPr txBox="1"/>
-          <p:nvPr/>
-        </p:nvSpPr>
-        <p:spPr>
-          <a:xfrm>
-            <a:off x="731520" y="365760"/>
-            <a:ext cx="10698480" cy="1005840"/>
-          </a:xfrm>
-          <a:prstGeom prst="rect">
-            <a:avLst/>
-          </a:prstGeom>
-          <a:noFill/>
-        </p:spPr>
-        <p:txBody>
-          <a:bodyPr wrap="square">
-            <a:spAutoFit/>
-          </a:bodyPr>
-          <a:lstStyle/>
-          <a:p>
-            <a:pPr>
-              <a:defRPr sz="1200" b="1">
-                <a:solidFill>
-                  <a:srgbClr val="FF4757"/>
-                </a:solidFill>
-                <a:latin typeface="Malgun Gothic"/>
-              </a:defRPr>
-            </a:pPr>
-            <a:r>
-              <a:t>에이닷(A.DOT) 영어학원 성장의 3대 필수 조건</a:t>
-            </a:r>
-          </a:p>
-          <a:p>
-            <a:pPr>
-              <a:defRPr sz="2500" b="1">
-                <a:solidFill>
-                  <a:srgbClr val="FFFFFF"/>
-                </a:solidFill>
-                <a:latin typeface="Malgun Gothic"/>
-              </a:defRPr>
-            </a:pPr>
-            <a:r>
-              <a:t>3. ⭐ 서울대 입결 TOP 30 고등학교 - 직관적 학구열 파악</a:t>
-            </a:r>
-          </a:p>
-        </p:txBody>
-      </p:sp>
-      <p:sp>
-        <p:nvSpPr>
-          <p:cNvPr id="4" name="Rounded Rectangle 3"/>
-          <p:cNvSpPr/>
-          <p:nvPr/>
-        </p:nvSpPr>
-        <p:spPr>
-          <a:xfrm>
-            <a:off x="731520" y="1645920"/>
-            <a:ext cx="5120640" cy="4389120"/>
-          </a:xfrm>
-          <a:prstGeom prst="roundRect">
-            <a:avLst/>
-          </a:prstGeom>
-          <a:solidFill>
-            <a:srgbClr val="1E293B"/>
-          </a:solidFill>
-          <a:ln w="25400">
-            <a:solidFill>
-              <a:srgbClr val="F59E0B"/>
-            </a:solidFill>
-          </a:ln>
-        </p:spPr>
-        <p:style>
-          <a:lnRef idx="1">
-            <a:schemeClr val="accent1"/>
-          </a:lnRef>
-          <a:fillRef idx="3">
-            <a:schemeClr val="accent1"/>
-          </a:fillRef>
-          <a:effectRef idx="2">
-            <a:schemeClr val="accent1"/>
-          </a:effectRef>
-          <a:fontRef idx="minor">
-            <a:schemeClr val="lt1"/>
-          </a:fontRef>
-        </p:style>
-        <p:txBody>
-          <a:bodyPr rtlCol="0" anchor="ctr" wrap="square" lIns="365760" tIns="365760"/>
-          <a:lstStyle/>
-          <a:p>
-            <a:pPr algn="ctr">
-              <a:defRPr sz="2000" b="1">
-                <a:solidFill>
-                  <a:srgbClr val="F59E0B"/>
-                </a:solidFill>
-                <a:latin typeface="Malgun Gothic"/>
-              </a:defRPr>
-            </a:pPr>
-            <a:r>
-              <a:t>⭐ 서울대 TOP 30 시각화의 의의</a:t>
-            </a:r>
-          </a:p>
-          <a:p>
-            <a:pPr>
-              <a:spcBef>
-                <a:spcPts val="1400"/>
-              </a:spcBef>
-              <a:defRPr sz="1350">
-                <a:solidFill>
-                  <a:srgbClr val="FFFFFF"/>
-                </a:solidFill>
-                <a:latin typeface="Malgun Gothic"/>
-              </a:defRPr>
-            </a:pPr>
-            <a:r>
-              <a:t>• 고등학교 중 '서울대 합격자수 상위 30개교' 마커 표시</a:t>
-            </a:r>
-            <a:br/>
-            <a:br/>
-            <a:r>
-              <a:t>• 지역 학구열의 직관적 파악:</a:t>
-            </a:r>
-            <a:br/>
-            <a:r>
-              <a:t>  - 지도에서 해당 지역에 TOP 30 고등학교가 위치해 있는지 한눈에 즉시 확인.</a:t>
-            </a:r>
-            <a:br/>
-            <a:br/>
-            <a:r>
-              <a:t>  - 학구열이 높은 지역일수록 학부모의 교육 투자 성향이 강하고 고난도 영어 코칭(에이닷) 수요가 폭발적임.</a:t>
-            </a:r>
-            <a:br/>
-            <a:br/>
-            <a:r>
-              <a:t>  - 프리미엄 입지 판정의 단초 역할 수행.</a:t>
-            </a:r>
-          </a:p>
-        </p:txBody>
-      </p:sp>
-      <p:sp>
-        <p:nvSpPr>
-          <p:cNvPr id="5" name="Rounded Rectangle 4"/>
-          <p:cNvSpPr/>
-          <p:nvPr/>
-        </p:nvSpPr>
-        <p:spPr>
-          <a:xfrm>
-            <a:off x="6217920" y="1645920"/>
-            <a:ext cx="5212080" cy="4389120"/>
-          </a:xfrm>
-          <a:prstGeom prst="roundRect">
-            <a:avLst/>
-          </a:prstGeom>
-          <a:solidFill>
-            <a:srgbClr val="1E293B"/>
-          </a:solidFill>
-          <a:ln w="25400">
-            <a:solidFill>
-              <a:srgbClr val="FF4757"/>
-            </a:solidFill>
-          </a:ln>
-        </p:spPr>
-        <p:style>
-          <a:lnRef idx="1">
-            <a:schemeClr val="accent1"/>
-          </a:lnRef>
-          <a:fillRef idx="3">
-            <a:schemeClr val="accent1"/>
-          </a:fillRef>
-          <a:effectRef idx="2">
-            <a:schemeClr val="accent1"/>
-          </a:effectRef>
-          <a:fontRef idx="minor">
-            <a:schemeClr val="lt1"/>
-          </a:fontRef>
-        </p:style>
-        <p:txBody>
-          <a:bodyPr rtlCol="0" anchor="ctr" wrap="square" lIns="365760" tIns="365760"/>
-          <a:lstStyle/>
-          <a:p>
-            <a:pPr algn="ctr">
-              <a:defRPr sz="2000" b="1">
-                <a:solidFill>
-                  <a:srgbClr val="FF4757"/>
-                </a:solidFill>
-                <a:latin typeface="Malgun Gothic"/>
-              </a:defRPr>
-            </a:pPr>
-            <a:r>
-              <a:t>📈 학구열과 에이닷 매출의 상관관계</a:t>
-            </a:r>
-          </a:p>
-          <a:p>
-            <a:pPr>
-              <a:spcBef>
-                <a:spcPts val="1400"/>
-              </a:spcBef>
-              <a:defRPr sz="1350">
-                <a:solidFill>
-                  <a:srgbClr val="FFFFFF"/>
-                </a:solidFill>
-                <a:latin typeface="Malgun Gothic"/>
-              </a:defRPr>
-            </a:pPr>
-            <a:r>
-              <a:t>1️⃣ 고학구열 지역의 수강생 LTV (평생가치) 증대:</a:t>
-            </a:r>
-            <a:br/>
-            <a:r>
-              <a:t>    내신 및 수능 대세를 이끄는 명문고 배후지로 장기 수강률 확보.</a:t>
-            </a:r>
-            <a:br/>
-            <a:br/>
-            <a:r>
-              <a:t>2️⃣ 마케팅 효율 및 입소문 확산 가속:</a:t>
-            </a:r>
-            <a:br/>
-            <a:r>
-              <a:t>    학부모 커뮤니티가 활성화되어 입소문을 통한 성과 전파가 매우 빠름.</a:t>
-            </a:r>
-            <a:br/>
-            <a:br/>
-            <a:r>
-              <a:t>3️⃣ 에이닷 브랜드 고급화 시너지:</a:t>
-            </a:r>
-            <a:br/>
-            <a:r>
-              <a:t>    명문고 상권 입점으로 지역 내 대표 영어학원으로 포지셔닝.</a:t>
-            </a:r>
-          </a:p>
-        </p:txBody>
-      </p:sp>
-    </p:spTree>
-  </p:cSld>
-  <p:clrMapOvr>
-    <a:masterClrMapping/>
-  </p:clrMapOvr>
-</p:sld>
-</file>
-
-<file path=ppt/slides/slide5.xml><?xml version="1.0" encoding="utf-8"?>
-<p:sld xmlns:a="http://schemas.openxmlformats.org/drawingml/2006/main" xmlns:p="http://schemas.openxmlformats.org/presentationml/2006/main" xmlns:r="http://schemas.openxmlformats.org/officeDocument/2006/relationships">
-  <p:cSld>
-    <p:spTree>
-      <p:nvGrpSpPr>
-        <p:cNvPr id="1" name=""/>
-        <p:cNvGrpSpPr/>
-        <p:nvPr/>
-      </p:nvGrpSpPr>
-      <p:grpSpPr/>
-      <p:sp>
-        <p:nvSpPr>
-          <p:cNvPr id="2" name="Rectangle 1"/>
-          <p:cNvSpPr/>
-          <p:nvPr/>
-        </p:nvSpPr>
-        <p:spPr>
-          <a:xfrm>
-            <a:off x="0" y="0"/>
-            <a:ext cx="12191695" cy="6858000"/>
-          </a:xfrm>
-          <a:prstGeom prst="rect">
-            <a:avLst/>
-          </a:prstGeom>
-          <a:solidFill>
-            <a:srgbClr val="0F172A"/>
-          </a:solidFill>
-          <a:ln>
-            <a:noFill/>
-          </a:ln>
-        </p:spPr>
-        <p:style>
-          <a:lnRef idx="1">
-            <a:schemeClr val="accent1"/>
-          </a:lnRef>
-          <a:fillRef idx="3">
-            <a:schemeClr val="accent1"/>
-          </a:fillRef>
-          <a:effectRef idx="2">
-            <a:schemeClr val="accent1"/>
-          </a:effectRef>
-          <a:fontRef idx="minor">
-            <a:schemeClr val="lt1"/>
-          </a:fontRef>
-        </p:style>
-        <p:txBody>
-          <a:bodyPr rtlCol="0" anchor="ctr"/>
-          <a:lstStyle/>
-          <a:p>
-            <a:pPr algn="ctr"/>
-          </a:p>
-        </p:txBody>
-      </p:sp>
-      <p:sp>
-        <p:nvSpPr>
-          <p:cNvPr id="3" name="TextBox 2"/>
-          <p:cNvSpPr txBox="1"/>
-          <p:nvPr/>
-        </p:nvSpPr>
-        <p:spPr>
-          <a:xfrm>
-            <a:off x="731520" y="365760"/>
-            <a:ext cx="10698480" cy="1005840"/>
-          </a:xfrm>
-          <a:prstGeom prst="rect">
-            <a:avLst/>
-          </a:prstGeom>
-          <a:noFill/>
-        </p:spPr>
-        <p:txBody>
-          <a:bodyPr wrap="square">
-            <a:spAutoFit/>
-          </a:bodyPr>
-          <a:lstStyle/>
-          <a:p>
-            <a:pPr>
-              <a:defRPr sz="1200" b="1">
-                <a:solidFill>
-                  <a:srgbClr val="FF4757"/>
-                </a:solidFill>
-                <a:latin typeface="Malgun Gothic"/>
-              </a:defRPr>
-            </a:pPr>
-            <a:r>
-              <a:t>에이닷(A.DOT) 영어학원 성장의 3대 필수 조건</a:t>
-            </a:r>
-          </a:p>
-          <a:p>
-            <a:pPr>
-              <a:defRPr sz="2500" b="1">
-                <a:solidFill>
-                  <a:srgbClr val="FFFFFF"/>
-                </a:solidFill>
-                <a:latin typeface="Malgun Gothic"/>
-              </a:defRPr>
-            </a:pPr>
-            <a:r>
-              <a:t>4. 🏛️ 4년제 대학교의 2대 가치: 학구열 판단 + 강사 수급 용이성</a:t>
-            </a:r>
-          </a:p>
-        </p:txBody>
-      </p:sp>
-      <p:sp>
-        <p:nvSpPr>
-          <p:cNvPr id="4" name="Rounded Rectangle 3"/>
-          <p:cNvSpPr/>
-          <p:nvPr/>
-        </p:nvSpPr>
-        <p:spPr>
-          <a:xfrm>
-            <a:off x="731520" y="1645920"/>
-            <a:ext cx="5120640" cy="4389120"/>
-          </a:xfrm>
-          <a:prstGeom prst="roundRect">
-            <a:avLst/>
-          </a:prstGeom>
-          <a:solidFill>
-            <a:srgbClr val="1E293B"/>
-          </a:solidFill>
-          <a:ln w="25400">
-            <a:solidFill>
-              <a:srgbClr val="6366F1"/>
-            </a:solidFill>
-          </a:ln>
-        </p:spPr>
-        <p:style>
-          <a:lnRef idx="1">
-            <a:schemeClr val="accent1"/>
-          </a:lnRef>
-          <a:fillRef idx="3">
-            <a:schemeClr val="accent1"/>
-          </a:fillRef>
-          <a:effectRef idx="2">
-            <a:schemeClr val="accent1"/>
-          </a:effectRef>
-          <a:fontRef idx="minor">
-            <a:schemeClr val="lt1"/>
-          </a:fontRef>
-        </p:style>
-        <p:txBody>
-          <a:bodyPr rtlCol="0" anchor="ctr" wrap="square" lIns="365760" tIns="365760"/>
-          <a:lstStyle/>
-          <a:p>
-            <a:pPr algn="ctr">
-              <a:defRPr sz="2000" b="1">
-                <a:solidFill>
-                  <a:srgbClr val="6366F1"/>
-                </a:solidFill>
-                <a:latin typeface="Malgun Gothic"/>
-              </a:defRPr>
-            </a:pPr>
-            <a:r>
-              <a:t>🎓 1. 지역 학구열 지표로서의 가치</a:t>
-            </a:r>
-          </a:p>
-          <a:p>
-            <a:pPr>
-              <a:spcBef>
-                <a:spcPts val="1600"/>
-              </a:spcBef>
-              <a:defRPr sz="1400">
-                <a:solidFill>
-                  <a:srgbClr val="FFFFFF"/>
-                </a:solidFill>
-                <a:latin typeface="Malgun Gothic"/>
-              </a:defRPr>
-            </a:pPr>
-            <a:r>
-              <a:t>• 4년제 대학교 입지 지역의 문화적 특징:</a:t>
-            </a:r>
-            <a:br/>
-            <a:r>
-              <a:t>  - 지적 분위기와 고학력 인구 비중이 높아 지역 전체의 학구열 수준 파악 가능.</a:t>
-            </a:r>
-            <a:br/>
-            <a:br/>
-            <a:r>
-              <a:t>  - 학부모들의 대학 입시 관심도가 높아 고급 인강/학원 코칭 수요가 지속적으로 높음.</a:t>
-            </a:r>
-          </a:p>
-        </p:txBody>
-      </p:sp>
-      <p:sp>
-        <p:nvSpPr>
-          <p:cNvPr id="5" name="Rounded Rectangle 4"/>
-          <p:cNvSpPr/>
-          <p:nvPr/>
-        </p:nvSpPr>
-        <p:spPr>
-          <a:xfrm>
-            <a:off x="6217920" y="1645920"/>
-            <a:ext cx="5212080" cy="4389120"/>
-          </a:xfrm>
-          <a:prstGeom prst="roundRect">
-            <a:avLst/>
-          </a:prstGeom>
-          <a:solidFill>
-            <a:srgbClr val="1E293B"/>
-          </a:solidFill>
-          <a:ln w="25400">
-            <a:solidFill>
-              <a:srgbClr val="2ECC71"/>
-            </a:solidFill>
-          </a:ln>
-        </p:spPr>
-        <p:style>
-          <a:lnRef idx="1">
-            <a:schemeClr val="accent1"/>
-          </a:lnRef>
-          <a:fillRef idx="3">
-            <a:schemeClr val="accent1"/>
-          </a:fillRef>
-          <a:effectRef idx="2">
-            <a:schemeClr val="accent1"/>
-          </a:effectRef>
-          <a:fontRef idx="minor">
-            <a:schemeClr val="lt1"/>
-          </a:fontRef>
-        </p:style>
-        <p:txBody>
-          <a:bodyPr rtlCol="0" anchor="ctr" wrap="square" lIns="365760" tIns="365760"/>
-          <a:lstStyle/>
-          <a:p>
-            <a:pPr algn="ctr">
-              <a:defRPr sz="2000" b="1">
-                <a:solidFill>
-                  <a:srgbClr val="2ECC71"/>
-                </a:solidFill>
-                <a:latin typeface="Malgun Gothic"/>
-              </a:defRPr>
-            </a:pPr>
-            <a:r>
-              <a:t>🤝 2. 강사 구인 용이성 (수급 원활도)</a:t>
-            </a:r>
-          </a:p>
-          <a:p>
-            <a:pPr>
-              <a:spcBef>
-                <a:spcPts val="1600"/>
-              </a:spcBef>
-              <a:defRPr sz="1400">
-                <a:solidFill>
-                  <a:srgbClr val="FFFFFF"/>
-                </a:solidFill>
-                <a:latin typeface="Malgun Gothic"/>
-              </a:defRPr>
-            </a:pPr>
-            <a:r>
-              <a:t>• 우수한 강사 수급 리스크 원천 차단:</a:t>
-            </a:r>
-            <a:br/>
-            <a:r>
-              <a:t>  - 명문 대학생 및 대학원생 파트타임/전임 강사를 가까운 인근에서 수월하게 구인.</a:t>
-            </a:r>
-            <a:br/>
-            <a:br/>
-            <a:r>
-              <a:t>  - 강사 수급 난항으로 인한 개원 지연 및 휴원 위험을 방지하여 에이닷 네트워크 성장의 병목 해결.</a:t>
+              <a:t>빅데이터 결합으로 '에이닷 입지 AI Score' 산출하여 1순위 추천</a:t>
             </a:r>
           </a:p>
         </p:txBody>
@@ -4647,7 +4710,7 @@
               </a:defRPr>
             </a:pPr>
             <a:r>
-              <a:t>5. 🎯 RDB 추천입지 모델 &amp; 경영진 최종 결론</a:t>
+              <a:t>5. 경영진 최종 결론 &amp; 비즈니스 임팩트 제언</a:t>
             </a:r>
           </a:p>
         </p:txBody>
@@ -4702,7 +4765,7 @@
               </a:defRPr>
             </a:pPr>
             <a:r>
-              <a:t>💡 본 웹앱은 에이닷 성장의 3대 축 중 '상권 분석'의 최첨단 표준 시뮬레이터입니다.</a:t>
+              <a:t>💡 본 웹앱은 에이닷 성장의 핵심 축인 '상권 분석'의 표준 시뮬레이터입니다.</a:t>
             </a:r>
           </a:p>
           <a:p>
@@ -4710,7 +4773,7 @@
               <a:spcBef>
                 <a:spcPts val="1600"/>
               </a:spcBef>
-              <a:defRPr sz="1450">
+              <a:defRPr sz="1400">
                 <a:solidFill>
                   <a:srgbClr val="FFFFFF"/>
                 </a:solidFill>
@@ -4718,17 +4781,17 @@
               </a:defRPr>
             </a:pPr>
             <a:r>
-              <a:t>• 콘텐츠와 우수 강사진이 준비되어 있다면, 마지막 성공 열쇠는 '상권 분석'입니다.</a:t>
+              <a:t>• 추천입지를 3개 유형(🔥초희소형/⚡세대밀집/🖤메가타겟)으로 자동 분류하여 한눈에 파악하고 전략적 진출 가능.</a:t>
             </a:r>
             <a:br/>
             <a:br/>
             <a:r>
-              <a:t>• 본 웹앱은 수강생/잠재고객/세대수/학원수 분석은 물론, ⭐ 서울대 TOP30과 🏛️ 4년제 대학교 데이터로 '학구열'과 '강사 구인 용이성'까지 직관적으로 판정합니다.</a:t>
+              <a:t>• ⭐ 서울대 TOP30 및 🏛️ 4년제 대학 입지로 '학구열'과 '강사 구인 용이성'을 완벽하게 검증.</a:t>
             </a:r>
             <a:br/>
             <a:br/>
             <a:r>
-              <a:t>• 기존 지점 3km 이격으로 자기잠식을 막고 독점적 🔥 초희소형(학원&lt;50개) 지역을 우선 진출하여 실패 없는 전국 1위 성장을 견인할 것을 제언합니다.</a:t>
+              <a:t>• 향후 3개년 학원수 추이 + 아파트 매매가(구매력) + 대학 수시/수능 입결 빅데이터 고도화로 최적 입지조건을 자동 산출하여 에이닷의 전국 1위 기하급수적 성장을 견인할 것을 제언합니다.</a:t>
             </a:r>
           </a:p>
         </p:txBody>

</xml_diff>